<commit_message>
docs: cover all five judging criteria on the pitch slide
</commit_message>
<xml_diff>
--- a/docs/recallops-pitch.pptx
+++ b/docs/recallops-pitch.pptx
@@ -2,13 +2,13 @@
 <file path=ppt/presentation.xml><?xml version="1.0" encoding="utf-8"?>
 <p:presentation xmlns:p="http://schemas.openxmlformats.org/presentationml/2006/main">
   <p:sldMasterIdLst>
-    <p:sldMasterId xmlns:r="http://schemas.openxmlformats.org/officeDocument/2006/relationships" id="2147483648" r:id="Rad75382ba8194be0"/>
+    <p:sldMasterId xmlns:r="http://schemas.openxmlformats.org/officeDocument/2006/relationships" id="2147483648" r:id="Ra98006ccf63d4c86"/>
   </p:sldMasterIdLst>
   <p:notesMasterIdLst>
-    <p:notesMasterId xmlns:r="http://schemas.openxmlformats.org/officeDocument/2006/relationships" r:id="R2a6e8f54d9704d82"/>
+    <p:notesMasterId xmlns:r="http://schemas.openxmlformats.org/officeDocument/2006/relationships" r:id="R0e9e8348e5644972"/>
   </p:notesMasterIdLst>
   <p:sldIdLst>
-    <p:sldId xmlns:r="http://schemas.openxmlformats.org/officeDocument/2006/relationships" id="256" r:id="R53636b247d104e27"/>
+    <p:sldId xmlns:r="http://schemas.openxmlformats.org/officeDocument/2006/relationships" id="256" r:id="R2f376dcb157a4d78"/>
   </p:sldIdLst>
   <p:sldSz cx="12192000" cy="6858000"/>
   <p:notesSz cx="6858000" cy="9144000"/>
@@ -442,7 +442,47 @@
           <a:lstStyle xmlns:a="http://schemas.openxmlformats.org/drawingml/2006/main"/>
           <a:p xmlns:a="http://schemas.openxmlformats.org/drawingml/2006/main">
             <a:r>
-              <a:t>Product implementation: backend/app/agents/investigator.py, backend/app/services/investigator_evidence.py and docs/investigator-guide.md. Public official recall source: https://rappel.conso.gouv.fr/fiche-rappel/17010/Interne (historical recall fixture). Customer hypothesis and proposed first-user route: docs/pilot-plan.md. This slide presents a prototype and a proposed pilot. No customer adoption, measured time saving, independently validated accuracy, market size, or hosted Aiven deployment is claimed. Demo stock and delivery records are fictional. Internal holds do not change a real checkout system. Suggested spoken pitch: A grocery operator needs to identify the recalled batch, not just a matching barcode. RecallOps searches the available delivery records, asks for an explicit stock association, and preserves the source behind the decision. Our first pilot would compare the existing manual process with supervised historical investigations using authorized exports.</a:t>
+              <a:t>RecallOps single-slide pitch. Five criteria follow the supplied Future Founders: Data-Centric Agents brief.</a:t>
+            </a:r>
+          </a:p>
+          <a:p xmlns:a="http://schemas.openxmlformats.org/drawingml/2006/main">
+            <a:r>
+              <a:t/>
+            </a:r>
+          </a:p>
+          <a:p xmlns:a="http://schemas.openxmlformats.org/drawingml/2006/main">
+            <a:r>
+              <a:t>Customer Problem &amp; Product Value: grocery operators must connect recall batches to store stock when batch records are missing. This is a customer hypothesis for supervised pilots, with no adoption or measured time saving claimed.</a:t>
+            </a:r>
+          </a:p>
+          <a:p xmlns:a="http://schemas.openxmlformats.org/drawingml/2006/main">
+            <a:r>
+              <a:t>Agent Capability: a bounded investigator retrieves evidence, requests explicit human document-to-stock association and reassesses as evidence changes. The optional model can choose allowlisted read-only retrieval actions. Deterministic checks govern stock decisions and internal holds. Demo: 24 unknown-batch packets become affected after confirmation of D104, while 18 other-batch packets are outside this specific recall. A contradiction reopens review and preserves the hold. This is an internal workflow, not a point-of-sale block.</a:t>
+            </a:r>
+          </a:p>
+          <a:p xmlns:a="http://schemas.openxmlformats.org/drawingml/2006/main">
+            <a:r>
+              <a:t>Data at the Core: official RappelConso data, inventory and delivery documents live in PostgreSQL with versions, provenance and audit records. Durable events trigger investigation. Archived historical official recall: https://rappel.conso.gouv.fr/fiche-rappel/17010/Interne . Stock, delivery and supplier records are fictional.</a:t>
+            </a:r>
+          </a:p>
+          <a:p xmlns:a="http://schemas.openxmlformats.org/drawingml/2006/main">
+            <a:r>
+              <a:t>Evidence It Works: https://github.com/amithkm9/RecallOps/blob/main/docs/fresh-e2e-results.json . Recorded 2026-10-22. Twelve developer-authored synthetic cases, seven supplied human setup confirmations and zero model calls. Baseline matches 6/12 expected verdicts, adaptive with memory 12/12. Tool calls: baseline 134, fixed retrieval 202, adaptive with memory 152, adaptive without memory 132. Both adaptive variants and fixed retrieval match 12/12. Expected verdicts include review and conflict. This is not 100% autonomous resolution or independently validated production accuracy. Memory showed no accuracy gain. The isolated fresh report records 59 verification entries.</a:t>
+            </a:r>
+          </a:p>
+          <a:p xmlns:a="http://schemas.openxmlformats.org/drawingml/2006/main">
+            <a:r>
+              <a:t>Execution &amp; Pitch: working local end-to-end demo and public repository at https://github.com/amithkm9/RecallOps . Proposed first-user route: direct outreach to independent grocery operators for supervised historical pilots with authorized stock exports. Compare investigation time and supported decisions against their current process. No pilots or deployments are claimed. Aiven Runtime deployment remains pending. See https://github.com/amithkm9/RecallOps/blob/main/docs/pilot-plan.md .</a:t>
+            </a:r>
+          </a:p>
+          <a:p xmlns:a="http://schemas.openxmlformats.org/drawingml/2006/main">
+            <a:r>
+              <a:t/>
+            </a:r>
+          </a:p>
+          <a:p xmlns:a="http://schemas.openxmlformats.org/drawingml/2006/main">
+            <a:r>
+              <a:t>Suggested spoken pitch: RecallOps helps grocery operators establish which batches need action. When stock is missing a batch number, the investigator retrieves delivery evidence and asks an operator to confirm the association. Every decision retains its sources, and new evidence can reopen review. Our demo holds 24 affected packets and distinguishes 18 outside the recall. In twelve synthetic cases, the investigator matched twelve expected verdicts versus six for the baseline, with human confirmations supplied. Our next step is supervised grocery pilots to measure investigation time and decision quality.</a:t>
             </a:r>
           </a:p>
         </p:txBody>
@@ -510,7 +550,7 @@
   </p:cSld>
   <p:clrMap bg1="lt1" tx1="dk1" bg2="lt2" tx2="dk2" accent1="accent1" accent2="accent2" accent3="accent3" accent4="accent4" accent5="accent5" accent6="accent6" hlink="hlink" folHlink="folHlink"/>
   <p:sldLayoutIdLst>
-    <p:sldLayoutId xmlns:r="http://schemas.openxmlformats.org/officeDocument/2006/relationships" id="2147483649" r:id="R1a0dbffc69b8449c"/>
+    <p:sldLayoutId xmlns:r="http://schemas.openxmlformats.org/officeDocument/2006/relationships" id="2147483649" r:id="Rb7e4c7d4d6434590"/>
   </p:sldLayoutIdLst>
   <p:txStyles>
     <p:titleStyle>
@@ -1072,8 +1112,8 @@
         </p:nvSpPr>
         <p:spPr>
           <a:xfrm xmlns:a="http://schemas.openxmlformats.org/drawingml/2006/main">
-            <a:off x="609600" y="419100"/>
-            <a:ext cx="6667500" cy="619125"/>
+            <a:off x="457200" y="266700"/>
+            <a:ext cx="10953750" cy="619125"/>
           </a:xfrm>
           <a:prstGeom xmlns:a="http://schemas.openxmlformats.org/drawingml/2006/main" prst="rect">
             <a:avLst/>
@@ -1084,12 +1124,114 @@
           </a:ln>
         </p:spPr>
         <p:txBody>
-          <a:bodyPr xmlns:a="http://schemas.openxmlformats.org/drawingml/2006/main">
+          <a:bodyPr xmlns:a="http://schemas.openxmlformats.org/drawingml/2006/main" lIns="0" tIns="0" rIns="0" bIns="0">
             <a:noAutofit/>
           </a:bodyPr>
-          <a:lstStyle xmlns:a="http://schemas.openxmlformats.org/drawingml/2006/main"/>
+          <a:lstStyle xmlns:a="http://schemas.openxmlformats.org/drawingml/2006/main">
+            <a:defPPr>
+              <a:defRPr sz="3900" b="1">
+                <a:solidFill>
+                  <a:srgbClr val="174D46"/>
+                </a:solidFill>
+                <a:latin typeface="Helvetica Neue"/>
+                <a:ea typeface="Helvetica Neue"/>
+                <a:cs typeface="Helvetica Neue"/>
+              </a:defRPr>
+            </a:defPPr>
+            <a:lvl1pPr>
+              <a:defRPr sz="3900" b="1">
+                <a:solidFill>
+                  <a:srgbClr val="174D46"/>
+                </a:solidFill>
+                <a:latin typeface="Helvetica Neue"/>
+                <a:ea typeface="Helvetica Neue"/>
+                <a:cs typeface="Helvetica Neue"/>
+              </a:defRPr>
+            </a:lvl1pPr>
+            <a:lvl2pPr>
+              <a:defRPr sz="3900" b="1">
+                <a:solidFill>
+                  <a:srgbClr val="174D46"/>
+                </a:solidFill>
+                <a:latin typeface="Helvetica Neue"/>
+                <a:ea typeface="Helvetica Neue"/>
+                <a:cs typeface="Helvetica Neue"/>
+              </a:defRPr>
+            </a:lvl2pPr>
+            <a:lvl3pPr>
+              <a:defRPr sz="3900" b="1">
+                <a:solidFill>
+                  <a:srgbClr val="174D46"/>
+                </a:solidFill>
+                <a:latin typeface="Helvetica Neue"/>
+                <a:ea typeface="Helvetica Neue"/>
+                <a:cs typeface="Helvetica Neue"/>
+              </a:defRPr>
+            </a:lvl3pPr>
+            <a:lvl4pPr>
+              <a:defRPr sz="3900" b="1">
+                <a:solidFill>
+                  <a:srgbClr val="174D46"/>
+                </a:solidFill>
+                <a:latin typeface="Helvetica Neue"/>
+                <a:ea typeface="Helvetica Neue"/>
+                <a:cs typeface="Helvetica Neue"/>
+              </a:defRPr>
+            </a:lvl4pPr>
+            <a:lvl5pPr>
+              <a:defRPr sz="3900" b="1">
+                <a:solidFill>
+                  <a:srgbClr val="174D46"/>
+                </a:solidFill>
+                <a:latin typeface="Helvetica Neue"/>
+                <a:ea typeface="Helvetica Neue"/>
+                <a:cs typeface="Helvetica Neue"/>
+              </a:defRPr>
+            </a:lvl5pPr>
+            <a:lvl6pPr>
+              <a:defRPr sz="3900" b="1">
+                <a:solidFill>
+                  <a:srgbClr val="174D46"/>
+                </a:solidFill>
+                <a:latin typeface="Helvetica Neue"/>
+                <a:ea typeface="Helvetica Neue"/>
+                <a:cs typeface="Helvetica Neue"/>
+              </a:defRPr>
+            </a:lvl6pPr>
+            <a:lvl7pPr>
+              <a:defRPr sz="3900" b="1">
+                <a:solidFill>
+                  <a:srgbClr val="174D46"/>
+                </a:solidFill>
+                <a:latin typeface="Helvetica Neue"/>
+                <a:ea typeface="Helvetica Neue"/>
+                <a:cs typeface="Helvetica Neue"/>
+              </a:defRPr>
+            </a:lvl7pPr>
+            <a:lvl8pPr>
+              <a:defRPr sz="3900" b="1">
+                <a:solidFill>
+                  <a:srgbClr val="174D46"/>
+                </a:solidFill>
+                <a:latin typeface="Helvetica Neue"/>
+                <a:ea typeface="Helvetica Neue"/>
+                <a:cs typeface="Helvetica Neue"/>
+              </a:defRPr>
+            </a:lvl8pPr>
+            <a:lvl9pPr>
+              <a:defRPr sz="3900" b="1">
+                <a:solidFill>
+                  <a:srgbClr val="174D46"/>
+                </a:solidFill>
+                <a:latin typeface="Helvetica Neue"/>
+                <a:ea typeface="Helvetica Neue"/>
+                <a:cs typeface="Helvetica Neue"/>
+              </a:defRPr>
+            </a:lvl9pPr>
+          </a:lstStyle>
           <a:p xmlns:a="http://schemas.openxmlformats.org/drawingml/2006/main">
             <a:pPr>
+              <a:buNone/>
               <a:defRPr sz="3900" b="1">
                 <a:solidFill>
                   <a:srgbClr val="174D46"/>
@@ -1129,8 +1271,8 @@
         </p:nvSpPr>
         <p:spPr>
           <a:xfrm xmlns:a="http://schemas.openxmlformats.org/drawingml/2006/main">
-            <a:off x="609600" y="1533525"/>
-            <a:ext cx="6191250" cy="1714500"/>
+            <a:off x="457200" y="933450"/>
+            <a:ext cx="11277600" cy="400050"/>
           </a:xfrm>
           <a:prstGeom xmlns:a="http://schemas.openxmlformats.org/drawingml/2006/main" prst="rect">
             <a:avLst/>
@@ -1141,15 +1283,117 @@
           </a:ln>
         </p:spPr>
         <p:txBody>
-          <a:bodyPr xmlns:a="http://schemas.openxmlformats.org/drawingml/2006/main">
+          <a:bodyPr xmlns:a="http://schemas.openxmlformats.org/drawingml/2006/main" lIns="0" tIns="0" rIns="0" bIns="0">
             <a:noAutofit/>
           </a:bodyPr>
-          <a:lstStyle xmlns:a="http://schemas.openxmlformats.org/drawingml/2006/main"/>
+          <a:lstStyle xmlns:a="http://schemas.openxmlformats.org/drawingml/2006/main">
+            <a:defPPr>
+              <a:defRPr sz="2025" b="0">
+                <a:solidFill>
+                  <a:srgbClr val="345D54"/>
+                </a:solidFill>
+                <a:latin typeface="Helvetica Neue"/>
+                <a:ea typeface="Helvetica Neue"/>
+                <a:cs typeface="Helvetica Neue"/>
+              </a:defRPr>
+            </a:defPPr>
+            <a:lvl1pPr>
+              <a:defRPr sz="2025" b="0">
+                <a:solidFill>
+                  <a:srgbClr val="345D54"/>
+                </a:solidFill>
+                <a:latin typeface="Helvetica Neue"/>
+                <a:ea typeface="Helvetica Neue"/>
+                <a:cs typeface="Helvetica Neue"/>
+              </a:defRPr>
+            </a:lvl1pPr>
+            <a:lvl2pPr>
+              <a:defRPr sz="2025" b="0">
+                <a:solidFill>
+                  <a:srgbClr val="345D54"/>
+                </a:solidFill>
+                <a:latin typeface="Helvetica Neue"/>
+                <a:ea typeface="Helvetica Neue"/>
+                <a:cs typeface="Helvetica Neue"/>
+              </a:defRPr>
+            </a:lvl2pPr>
+            <a:lvl3pPr>
+              <a:defRPr sz="2025" b="0">
+                <a:solidFill>
+                  <a:srgbClr val="345D54"/>
+                </a:solidFill>
+                <a:latin typeface="Helvetica Neue"/>
+                <a:ea typeface="Helvetica Neue"/>
+                <a:cs typeface="Helvetica Neue"/>
+              </a:defRPr>
+            </a:lvl3pPr>
+            <a:lvl4pPr>
+              <a:defRPr sz="2025" b="0">
+                <a:solidFill>
+                  <a:srgbClr val="345D54"/>
+                </a:solidFill>
+                <a:latin typeface="Helvetica Neue"/>
+                <a:ea typeface="Helvetica Neue"/>
+                <a:cs typeface="Helvetica Neue"/>
+              </a:defRPr>
+            </a:lvl4pPr>
+            <a:lvl5pPr>
+              <a:defRPr sz="2025" b="0">
+                <a:solidFill>
+                  <a:srgbClr val="345D54"/>
+                </a:solidFill>
+                <a:latin typeface="Helvetica Neue"/>
+                <a:ea typeface="Helvetica Neue"/>
+                <a:cs typeface="Helvetica Neue"/>
+              </a:defRPr>
+            </a:lvl5pPr>
+            <a:lvl6pPr>
+              <a:defRPr sz="2025" b="0">
+                <a:solidFill>
+                  <a:srgbClr val="345D54"/>
+                </a:solidFill>
+                <a:latin typeface="Helvetica Neue"/>
+                <a:ea typeface="Helvetica Neue"/>
+                <a:cs typeface="Helvetica Neue"/>
+              </a:defRPr>
+            </a:lvl6pPr>
+            <a:lvl7pPr>
+              <a:defRPr sz="2025" b="0">
+                <a:solidFill>
+                  <a:srgbClr val="345D54"/>
+                </a:solidFill>
+                <a:latin typeface="Helvetica Neue"/>
+                <a:ea typeface="Helvetica Neue"/>
+                <a:cs typeface="Helvetica Neue"/>
+              </a:defRPr>
+            </a:lvl7pPr>
+            <a:lvl8pPr>
+              <a:defRPr sz="2025" b="0">
+                <a:solidFill>
+                  <a:srgbClr val="345D54"/>
+                </a:solidFill>
+                <a:latin typeface="Helvetica Neue"/>
+                <a:ea typeface="Helvetica Neue"/>
+                <a:cs typeface="Helvetica Neue"/>
+              </a:defRPr>
+            </a:lvl8pPr>
+            <a:lvl9pPr>
+              <a:defRPr sz="2025" b="0">
+                <a:solidFill>
+                  <a:srgbClr val="345D54"/>
+                </a:solidFill>
+                <a:latin typeface="Helvetica Neue"/>
+                <a:ea typeface="Helvetica Neue"/>
+                <a:cs typeface="Helvetica Neue"/>
+              </a:defRPr>
+            </a:lvl9pPr>
+          </a:lstStyle>
           <a:p xmlns:a="http://schemas.openxmlformats.org/drawingml/2006/main">
             <a:pPr>
-              <a:defRPr sz="4800" b="1">
-                <a:solidFill>
-                  <a:srgbClr val="174D46"/>
+              <a:buNone/>
+              <a:defRPr sz="2025" b="0">
+                <a:solidFill>
+                  <a:srgbClr val="345D54"/>
                 </a:solidFill>
                 <a:latin typeface="Helvetica Neue"/>
                 <a:ea typeface="Helvetica Neue"/>
@@ -1157,38 +1401,15 @@
               </a:defRPr>
             </a:pPr>
             <a:r>
-              <a:rPr sz="4800" b="1">
-                <a:solidFill>
-                  <a:srgbClr val="174D46"/>
+              <a:rPr sz="2025" b="0">
+                <a:solidFill>
+                  <a:srgbClr val="345D54"/>
                 </a:solidFill>
                 <a:latin typeface="Helvetica Neue"/>
                 <a:ea typeface="Helvetica Neue"/>
                 <a:cs typeface="Helvetica Neue"/>
               </a:rPr>
-              <a:t>Which batches</a:t>
-            </a:r>
-          </a:p>
-          <a:p xmlns:a="http://schemas.openxmlformats.org/drawingml/2006/main">
-            <a:pPr>
-              <a:defRPr sz="4800" b="1">
-                <a:solidFill>
-                  <a:srgbClr val="174D46"/>
-                </a:solidFill>
-                <a:latin typeface="Helvetica Neue"/>
-                <a:ea typeface="Helvetica Neue"/>
-                <a:cs typeface="Helvetica Neue"/>
-              </a:defRPr>
-            </a:pPr>
-            <a:r>
-              <a:rPr sz="4800" b="1">
-                <a:solidFill>
-                  <a:srgbClr val="174D46"/>
-                </a:solidFill>
-                <a:latin typeface="Helvetica Neue"/>
-                <a:ea typeface="Helvetica Neue"/>
-                <a:cs typeface="Helvetica Neue"/>
-              </a:rPr>
-              <a:t>need action?</a:t>
+              <a:t>Which batches need action? Recall investigation for grocery operators.</a:t>
             </a:r>
           </a:p>
         </p:txBody>
@@ -1209,8 +1430,8 @@
         </p:nvSpPr>
         <p:spPr>
           <a:xfrm xmlns:a="http://schemas.openxmlformats.org/drawingml/2006/main">
-            <a:off x="647700" y="3457575"/>
-            <a:ext cx="5905500" cy="857250"/>
+            <a:off x="457200" y="1571625"/>
+            <a:ext cx="6191250" cy="285750"/>
           </a:xfrm>
           <a:prstGeom xmlns:a="http://schemas.openxmlformats.org/drawingml/2006/main" prst="rect">
             <a:avLst/>
@@ -1221,15 +1442,117 @@
           </a:ln>
         </p:spPr>
         <p:txBody>
-          <a:bodyPr xmlns:a="http://schemas.openxmlformats.org/drawingml/2006/main">
+          <a:bodyPr xmlns:a="http://schemas.openxmlformats.org/drawingml/2006/main" lIns="0" tIns="0" rIns="0" bIns="0">
             <a:noAutofit/>
           </a:bodyPr>
-          <a:lstStyle xmlns:a="http://schemas.openxmlformats.org/drawingml/2006/main"/>
+          <a:lstStyle xmlns:a="http://schemas.openxmlformats.org/drawingml/2006/main">
+            <a:defPPr>
+              <a:defRPr sz="1575" b="1">
+                <a:solidFill>
+                  <a:srgbClr val="174D46"/>
+                </a:solidFill>
+                <a:latin typeface="Helvetica Neue"/>
+                <a:ea typeface="Helvetica Neue"/>
+                <a:cs typeface="Helvetica Neue"/>
+              </a:defRPr>
+            </a:defPPr>
+            <a:lvl1pPr>
+              <a:defRPr sz="1575" b="1">
+                <a:solidFill>
+                  <a:srgbClr val="174D46"/>
+                </a:solidFill>
+                <a:latin typeface="Helvetica Neue"/>
+                <a:ea typeface="Helvetica Neue"/>
+                <a:cs typeface="Helvetica Neue"/>
+              </a:defRPr>
+            </a:lvl1pPr>
+            <a:lvl2pPr>
+              <a:defRPr sz="1575" b="1">
+                <a:solidFill>
+                  <a:srgbClr val="174D46"/>
+                </a:solidFill>
+                <a:latin typeface="Helvetica Neue"/>
+                <a:ea typeface="Helvetica Neue"/>
+                <a:cs typeface="Helvetica Neue"/>
+              </a:defRPr>
+            </a:lvl2pPr>
+            <a:lvl3pPr>
+              <a:defRPr sz="1575" b="1">
+                <a:solidFill>
+                  <a:srgbClr val="174D46"/>
+                </a:solidFill>
+                <a:latin typeface="Helvetica Neue"/>
+                <a:ea typeface="Helvetica Neue"/>
+                <a:cs typeface="Helvetica Neue"/>
+              </a:defRPr>
+            </a:lvl3pPr>
+            <a:lvl4pPr>
+              <a:defRPr sz="1575" b="1">
+                <a:solidFill>
+                  <a:srgbClr val="174D46"/>
+                </a:solidFill>
+                <a:latin typeface="Helvetica Neue"/>
+                <a:ea typeface="Helvetica Neue"/>
+                <a:cs typeface="Helvetica Neue"/>
+              </a:defRPr>
+            </a:lvl4pPr>
+            <a:lvl5pPr>
+              <a:defRPr sz="1575" b="1">
+                <a:solidFill>
+                  <a:srgbClr val="174D46"/>
+                </a:solidFill>
+                <a:latin typeface="Helvetica Neue"/>
+                <a:ea typeface="Helvetica Neue"/>
+                <a:cs typeface="Helvetica Neue"/>
+              </a:defRPr>
+            </a:lvl5pPr>
+            <a:lvl6pPr>
+              <a:defRPr sz="1575" b="1">
+                <a:solidFill>
+                  <a:srgbClr val="174D46"/>
+                </a:solidFill>
+                <a:latin typeface="Helvetica Neue"/>
+                <a:ea typeface="Helvetica Neue"/>
+                <a:cs typeface="Helvetica Neue"/>
+              </a:defRPr>
+            </a:lvl6pPr>
+            <a:lvl7pPr>
+              <a:defRPr sz="1575" b="1">
+                <a:solidFill>
+                  <a:srgbClr val="174D46"/>
+                </a:solidFill>
+                <a:latin typeface="Helvetica Neue"/>
+                <a:ea typeface="Helvetica Neue"/>
+                <a:cs typeface="Helvetica Neue"/>
+              </a:defRPr>
+            </a:lvl7pPr>
+            <a:lvl8pPr>
+              <a:defRPr sz="1575" b="1">
+                <a:solidFill>
+                  <a:srgbClr val="174D46"/>
+                </a:solidFill>
+                <a:latin typeface="Helvetica Neue"/>
+                <a:ea typeface="Helvetica Neue"/>
+                <a:cs typeface="Helvetica Neue"/>
+              </a:defRPr>
+            </a:lvl8pPr>
+            <a:lvl9pPr>
+              <a:defRPr sz="1575" b="1">
+                <a:solidFill>
+                  <a:srgbClr val="174D46"/>
+                </a:solidFill>
+                <a:latin typeface="Helvetica Neue"/>
+                <a:ea typeface="Helvetica Neue"/>
+                <a:cs typeface="Helvetica Neue"/>
+              </a:defRPr>
+            </a:lvl9pPr>
+          </a:lstStyle>
           <a:p xmlns:a="http://schemas.openxmlformats.org/drawingml/2006/main">
             <a:pPr>
-              <a:defRPr sz="2175" b="0">
-                <a:solidFill>
-                  <a:srgbClr val="345D54"/>
+              <a:buNone/>
+              <a:defRPr sz="1575" b="1">
+                <a:solidFill>
+                  <a:srgbClr val="174D46"/>
                 </a:solidFill>
                 <a:latin typeface="Helvetica Neue"/>
                 <a:ea typeface="Helvetica Neue"/>
@@ -1237,38 +1560,15 @@
               </a:defRPr>
             </a:pPr>
             <a:r>
-              <a:rPr sz="2175" b="0">
-                <a:solidFill>
-                  <a:srgbClr val="345D54"/>
+              <a:rPr sz="1575" b="1">
+                <a:solidFill>
+                  <a:srgbClr val="174D46"/>
                 </a:solidFill>
                 <a:latin typeface="Helvetica Neue"/>
                 <a:ea typeface="Helvetica Neue"/>
                 <a:cs typeface="Helvetica Neue"/>
               </a:rPr>
-              <a:t>Evidence-led recall investigation</a:t>
-            </a:r>
-          </a:p>
-          <a:p xmlns:a="http://schemas.openxmlformats.org/drawingml/2006/main">
-            <a:pPr>
-              <a:defRPr sz="2175" b="0">
-                <a:solidFill>
-                  <a:srgbClr val="345D54"/>
-                </a:solidFill>
-                <a:latin typeface="Helvetica Neue"/>
-                <a:ea typeface="Helvetica Neue"/>
-                <a:cs typeface="Helvetica Neue"/>
-              </a:defRPr>
-            </a:pPr>
-            <a:r>
-              <a:rPr sz="2175" b="0">
-                <a:solidFill>
-                  <a:srgbClr val="345D54"/>
-                </a:solidFill>
-                <a:latin typeface="Helvetica Neue"/>
-                <a:ea typeface="Helvetica Neue"/>
-                <a:cs typeface="Helvetica Neue"/>
-              </a:rPr>
-              <a:t>for grocery operators</a:t>
+              <a:t>1. Customer Problem &amp; Product Value</a:t>
             </a:r>
           </a:p>
         </p:txBody>
@@ -1289,8 +1589,8 @@
         </p:nvSpPr>
         <p:spPr>
           <a:xfrm xmlns:a="http://schemas.openxmlformats.org/drawingml/2006/main">
-            <a:off x="7239000" y="1590675"/>
-            <a:ext cx="4095750" cy="333375"/>
+            <a:off x="457200" y="1943100"/>
+            <a:ext cx="6238875" cy="723900"/>
           </a:xfrm>
           <a:prstGeom xmlns:a="http://schemas.openxmlformats.org/drawingml/2006/main" prst="rect">
             <a:avLst/>
@@ -1301,15 +1601,117 @@
           </a:ln>
         </p:spPr>
         <p:txBody>
-          <a:bodyPr xmlns:a="http://schemas.openxmlformats.org/drawingml/2006/main">
+          <a:bodyPr xmlns:a="http://schemas.openxmlformats.org/drawingml/2006/main" lIns="0" tIns="0" rIns="0" bIns="0">
             <a:noAutofit/>
           </a:bodyPr>
-          <a:lstStyle xmlns:a="http://schemas.openxmlformats.org/drawingml/2006/main"/>
+          <a:lstStyle xmlns:a="http://schemas.openxmlformats.org/drawingml/2006/main">
+            <a:defPPr>
+              <a:defRPr sz="1800" b="0">
+                <a:solidFill>
+                  <a:srgbClr val="253F39"/>
+                </a:solidFill>
+                <a:latin typeface="Helvetica Neue"/>
+                <a:ea typeface="Helvetica Neue"/>
+                <a:cs typeface="Helvetica Neue"/>
+              </a:defRPr>
+            </a:defPPr>
+            <a:lvl1pPr>
+              <a:defRPr sz="1800" b="0">
+                <a:solidFill>
+                  <a:srgbClr val="253F39"/>
+                </a:solidFill>
+                <a:latin typeface="Helvetica Neue"/>
+                <a:ea typeface="Helvetica Neue"/>
+                <a:cs typeface="Helvetica Neue"/>
+              </a:defRPr>
+            </a:lvl1pPr>
+            <a:lvl2pPr>
+              <a:defRPr sz="1800" b="0">
+                <a:solidFill>
+                  <a:srgbClr val="253F39"/>
+                </a:solidFill>
+                <a:latin typeface="Helvetica Neue"/>
+                <a:ea typeface="Helvetica Neue"/>
+                <a:cs typeface="Helvetica Neue"/>
+              </a:defRPr>
+            </a:lvl2pPr>
+            <a:lvl3pPr>
+              <a:defRPr sz="1800" b="0">
+                <a:solidFill>
+                  <a:srgbClr val="253F39"/>
+                </a:solidFill>
+                <a:latin typeface="Helvetica Neue"/>
+                <a:ea typeface="Helvetica Neue"/>
+                <a:cs typeface="Helvetica Neue"/>
+              </a:defRPr>
+            </a:lvl3pPr>
+            <a:lvl4pPr>
+              <a:defRPr sz="1800" b="0">
+                <a:solidFill>
+                  <a:srgbClr val="253F39"/>
+                </a:solidFill>
+                <a:latin typeface="Helvetica Neue"/>
+                <a:ea typeface="Helvetica Neue"/>
+                <a:cs typeface="Helvetica Neue"/>
+              </a:defRPr>
+            </a:lvl4pPr>
+            <a:lvl5pPr>
+              <a:defRPr sz="1800" b="0">
+                <a:solidFill>
+                  <a:srgbClr val="253F39"/>
+                </a:solidFill>
+                <a:latin typeface="Helvetica Neue"/>
+                <a:ea typeface="Helvetica Neue"/>
+                <a:cs typeface="Helvetica Neue"/>
+              </a:defRPr>
+            </a:lvl5pPr>
+            <a:lvl6pPr>
+              <a:defRPr sz="1800" b="0">
+                <a:solidFill>
+                  <a:srgbClr val="253F39"/>
+                </a:solidFill>
+                <a:latin typeface="Helvetica Neue"/>
+                <a:ea typeface="Helvetica Neue"/>
+                <a:cs typeface="Helvetica Neue"/>
+              </a:defRPr>
+            </a:lvl6pPr>
+            <a:lvl7pPr>
+              <a:defRPr sz="1800" b="0">
+                <a:solidFill>
+                  <a:srgbClr val="253F39"/>
+                </a:solidFill>
+                <a:latin typeface="Helvetica Neue"/>
+                <a:ea typeface="Helvetica Neue"/>
+                <a:cs typeface="Helvetica Neue"/>
+              </a:defRPr>
+            </a:lvl7pPr>
+            <a:lvl8pPr>
+              <a:defRPr sz="1800" b="0">
+                <a:solidFill>
+                  <a:srgbClr val="253F39"/>
+                </a:solidFill>
+                <a:latin typeface="Helvetica Neue"/>
+                <a:ea typeface="Helvetica Neue"/>
+                <a:cs typeface="Helvetica Neue"/>
+              </a:defRPr>
+            </a:lvl8pPr>
+            <a:lvl9pPr>
+              <a:defRPr sz="1800" b="0">
+                <a:solidFill>
+                  <a:srgbClr val="253F39"/>
+                </a:solidFill>
+                <a:latin typeface="Helvetica Neue"/>
+                <a:ea typeface="Helvetica Neue"/>
+                <a:cs typeface="Helvetica Neue"/>
+              </a:defRPr>
+            </a:lvl9pPr>
+          </a:lstStyle>
           <a:p xmlns:a="http://schemas.openxmlformats.org/drawingml/2006/main">
             <a:pPr>
-              <a:defRPr sz="1500" b="1">
-                <a:solidFill>
-                  <a:srgbClr val="174D46"/>
+              <a:buNone/>
+              <a:defRPr sz="1800" b="0">
+                <a:solidFill>
+                  <a:srgbClr val="253F39"/>
                 </a:solidFill>
                 <a:latin typeface="Helvetica Neue"/>
                 <a:ea typeface="Helvetica Neue"/>
@@ -1317,15 +1719,39 @@
               </a:defRPr>
             </a:pPr>
             <a:r>
-              <a:rPr sz="1500" b="1">
-                <a:solidFill>
-                  <a:srgbClr val="174D46"/>
+              <a:rPr sz="1800" b="0">
+                <a:solidFill>
+                  <a:srgbClr val="253F39"/>
                 </a:solidFill>
                 <a:latin typeface="Helvetica Neue"/>
                 <a:ea typeface="Helvetica Neue"/>
                 <a:cs typeface="Helvetica Neue"/>
               </a:rPr>
-              <a:t>THE PRODUCT</a:t>
+              <a:t>Missing batch records make recalls hard to act on.</a:t>
+            </a:r>
+          </a:p>
+          <a:p xmlns:a="http://schemas.openxmlformats.org/drawingml/2006/main">
+            <a:pPr>
+              <a:buNone/>
+              <a:defRPr sz="1800" b="0">
+                <a:solidFill>
+                  <a:srgbClr val="253F39"/>
+                </a:solidFill>
+                <a:latin typeface="Helvetica Neue"/>
+                <a:ea typeface="Helvetica Neue"/>
+                <a:cs typeface="Helvetica Neue"/>
+              </a:defRPr>
+            </a:pPr>
+            <a:r>
+              <a:rPr sz="1800" b="0">
+                <a:solidFill>
+                  <a:srgbClr val="253F39"/>
+                </a:solidFill>
+                <a:latin typeface="Helvetica Neue"/>
+                <a:ea typeface="Helvetica Neue"/>
+                <a:cs typeface="Helvetica Neue"/>
+              </a:rPr>
+              <a:t>Identify affected stock with traceable evidence.</a:t>
             </a:r>
           </a:p>
         </p:txBody>
@@ -1346,8 +1772,8 @@
         </p:nvSpPr>
         <p:spPr>
           <a:xfrm xmlns:a="http://schemas.openxmlformats.org/drawingml/2006/main">
-            <a:off x="7239000" y="2019300"/>
-            <a:ext cx="4191000" cy="1381125"/>
+            <a:off x="457200" y="2905125"/>
+            <a:ext cx="6191250" cy="285750"/>
           </a:xfrm>
           <a:prstGeom xmlns:a="http://schemas.openxmlformats.org/drawingml/2006/main" prst="rect">
             <a:avLst/>
@@ -1358,15 +1784,117 @@
           </a:ln>
         </p:spPr>
         <p:txBody>
-          <a:bodyPr xmlns:a="http://schemas.openxmlformats.org/drawingml/2006/main">
+          <a:bodyPr xmlns:a="http://schemas.openxmlformats.org/drawingml/2006/main" lIns="0" tIns="0" rIns="0" bIns="0">
             <a:noAutofit/>
           </a:bodyPr>
-          <a:lstStyle xmlns:a="http://schemas.openxmlformats.org/drawingml/2006/main"/>
+          <a:lstStyle xmlns:a="http://schemas.openxmlformats.org/drawingml/2006/main">
+            <a:defPPr>
+              <a:defRPr sz="1575" b="1">
+                <a:solidFill>
+                  <a:srgbClr val="174D46"/>
+                </a:solidFill>
+                <a:latin typeface="Helvetica Neue"/>
+                <a:ea typeface="Helvetica Neue"/>
+                <a:cs typeface="Helvetica Neue"/>
+              </a:defRPr>
+            </a:defPPr>
+            <a:lvl1pPr>
+              <a:defRPr sz="1575" b="1">
+                <a:solidFill>
+                  <a:srgbClr val="174D46"/>
+                </a:solidFill>
+                <a:latin typeface="Helvetica Neue"/>
+                <a:ea typeface="Helvetica Neue"/>
+                <a:cs typeface="Helvetica Neue"/>
+              </a:defRPr>
+            </a:lvl1pPr>
+            <a:lvl2pPr>
+              <a:defRPr sz="1575" b="1">
+                <a:solidFill>
+                  <a:srgbClr val="174D46"/>
+                </a:solidFill>
+                <a:latin typeface="Helvetica Neue"/>
+                <a:ea typeface="Helvetica Neue"/>
+                <a:cs typeface="Helvetica Neue"/>
+              </a:defRPr>
+            </a:lvl2pPr>
+            <a:lvl3pPr>
+              <a:defRPr sz="1575" b="1">
+                <a:solidFill>
+                  <a:srgbClr val="174D46"/>
+                </a:solidFill>
+                <a:latin typeface="Helvetica Neue"/>
+                <a:ea typeface="Helvetica Neue"/>
+                <a:cs typeface="Helvetica Neue"/>
+              </a:defRPr>
+            </a:lvl3pPr>
+            <a:lvl4pPr>
+              <a:defRPr sz="1575" b="1">
+                <a:solidFill>
+                  <a:srgbClr val="174D46"/>
+                </a:solidFill>
+                <a:latin typeface="Helvetica Neue"/>
+                <a:ea typeface="Helvetica Neue"/>
+                <a:cs typeface="Helvetica Neue"/>
+              </a:defRPr>
+            </a:lvl4pPr>
+            <a:lvl5pPr>
+              <a:defRPr sz="1575" b="1">
+                <a:solidFill>
+                  <a:srgbClr val="174D46"/>
+                </a:solidFill>
+                <a:latin typeface="Helvetica Neue"/>
+                <a:ea typeface="Helvetica Neue"/>
+                <a:cs typeface="Helvetica Neue"/>
+              </a:defRPr>
+            </a:lvl5pPr>
+            <a:lvl6pPr>
+              <a:defRPr sz="1575" b="1">
+                <a:solidFill>
+                  <a:srgbClr val="174D46"/>
+                </a:solidFill>
+                <a:latin typeface="Helvetica Neue"/>
+                <a:ea typeface="Helvetica Neue"/>
+                <a:cs typeface="Helvetica Neue"/>
+              </a:defRPr>
+            </a:lvl6pPr>
+            <a:lvl7pPr>
+              <a:defRPr sz="1575" b="1">
+                <a:solidFill>
+                  <a:srgbClr val="174D46"/>
+                </a:solidFill>
+                <a:latin typeface="Helvetica Neue"/>
+                <a:ea typeface="Helvetica Neue"/>
+                <a:cs typeface="Helvetica Neue"/>
+              </a:defRPr>
+            </a:lvl7pPr>
+            <a:lvl8pPr>
+              <a:defRPr sz="1575" b="1">
+                <a:solidFill>
+                  <a:srgbClr val="174D46"/>
+                </a:solidFill>
+                <a:latin typeface="Helvetica Neue"/>
+                <a:ea typeface="Helvetica Neue"/>
+                <a:cs typeface="Helvetica Neue"/>
+              </a:defRPr>
+            </a:lvl8pPr>
+            <a:lvl9pPr>
+              <a:defRPr sz="1575" b="1">
+                <a:solidFill>
+                  <a:srgbClr val="174D46"/>
+                </a:solidFill>
+                <a:latin typeface="Helvetica Neue"/>
+                <a:ea typeface="Helvetica Neue"/>
+                <a:cs typeface="Helvetica Neue"/>
+              </a:defRPr>
+            </a:lvl9pPr>
+          </a:lstStyle>
           <a:p xmlns:a="http://schemas.openxmlformats.org/drawingml/2006/main">
             <a:pPr>
-              <a:defRPr sz="1875" b="0">
-                <a:solidFill>
-                  <a:srgbClr val="253F39"/>
+              <a:buNone/>
+              <a:defRPr sz="1575" b="1">
+                <a:solidFill>
+                  <a:srgbClr val="174D46"/>
                 </a:solidFill>
                 <a:latin typeface="Helvetica Neue"/>
                 <a:ea typeface="Helvetica Neue"/>
@@ -1374,61 +1902,15 @@
               </a:defRPr>
             </a:pPr>
             <a:r>
-              <a:rPr sz="1875" b="0">
-                <a:solidFill>
-                  <a:srgbClr val="253F39"/>
+              <a:rPr sz="1575" b="1">
+                <a:solidFill>
+                  <a:srgbClr val="174D46"/>
                 </a:solidFill>
                 <a:latin typeface="Helvetica Neue"/>
                 <a:ea typeface="Helvetica Neue"/>
                 <a:cs typeface="Helvetica Neue"/>
               </a:rPr>
-              <a:t>Investigates missing batch records.</a:t>
-            </a:r>
-          </a:p>
-          <a:p xmlns:a="http://schemas.openxmlformats.org/drawingml/2006/main">
-            <a:pPr>
-              <a:defRPr sz="1875" b="0">
-                <a:solidFill>
-                  <a:srgbClr val="253F39"/>
-                </a:solidFill>
-                <a:latin typeface="Helvetica Neue"/>
-                <a:ea typeface="Helvetica Neue"/>
-                <a:cs typeface="Helvetica Neue"/>
-              </a:defRPr>
-            </a:pPr>
-            <a:r>
-              <a:rPr sz="1875" b="0">
-                <a:solidFill>
-                  <a:srgbClr val="253F39"/>
-                </a:solidFill>
-                <a:latin typeface="Helvetica Neue"/>
-                <a:ea typeface="Helvetica Neue"/>
-                <a:cs typeface="Helvetica Neue"/>
-              </a:rPr>
-              <a:t>Shows the source behind a decision.</a:t>
-            </a:r>
-          </a:p>
-          <a:p xmlns:a="http://schemas.openxmlformats.org/drawingml/2006/main">
-            <a:pPr>
-              <a:defRPr sz="1875" b="0">
-                <a:solidFill>
-                  <a:srgbClr val="253F39"/>
-                </a:solidFill>
-                <a:latin typeface="Helvetica Neue"/>
-                <a:ea typeface="Helvetica Neue"/>
-                <a:cs typeface="Helvetica Neue"/>
-              </a:defRPr>
-            </a:pPr>
-            <a:r>
-              <a:rPr sz="1875" b="0">
-                <a:solidFill>
-                  <a:srgbClr val="253F39"/>
-                </a:solidFill>
-                <a:latin typeface="Helvetica Neue"/>
-                <a:ea typeface="Helvetica Neue"/>
-                <a:cs typeface="Helvetica Neue"/>
-              </a:rPr>
-              <a:t>Keeps uncertainty in human review.</a:t>
+              <a:t>2. Agent Capability</a:t>
             </a:r>
           </a:p>
         </p:txBody>
@@ -1449,8 +1931,8 @@
         </p:nvSpPr>
         <p:spPr>
           <a:xfrm xmlns:a="http://schemas.openxmlformats.org/drawingml/2006/main">
-            <a:off x="7239000" y="3686175"/>
-            <a:ext cx="4095750" cy="333375"/>
+            <a:off x="457200" y="3276600"/>
+            <a:ext cx="6238875" cy="1009650"/>
           </a:xfrm>
           <a:prstGeom xmlns:a="http://schemas.openxmlformats.org/drawingml/2006/main" prst="rect">
             <a:avLst/>
@@ -1461,15 +1943,117 @@
           </a:ln>
         </p:spPr>
         <p:txBody>
-          <a:bodyPr xmlns:a="http://schemas.openxmlformats.org/drawingml/2006/main">
+          <a:bodyPr xmlns:a="http://schemas.openxmlformats.org/drawingml/2006/main" lIns="0" tIns="0" rIns="0" bIns="0">
             <a:noAutofit/>
           </a:bodyPr>
-          <a:lstStyle xmlns:a="http://schemas.openxmlformats.org/drawingml/2006/main"/>
+          <a:lstStyle xmlns:a="http://schemas.openxmlformats.org/drawingml/2006/main">
+            <a:defPPr>
+              <a:defRPr sz="1800" b="0">
+                <a:solidFill>
+                  <a:srgbClr val="253F39"/>
+                </a:solidFill>
+                <a:latin typeface="Helvetica Neue"/>
+                <a:ea typeface="Helvetica Neue"/>
+                <a:cs typeface="Helvetica Neue"/>
+              </a:defRPr>
+            </a:defPPr>
+            <a:lvl1pPr>
+              <a:defRPr sz="1800" b="0">
+                <a:solidFill>
+                  <a:srgbClr val="253F39"/>
+                </a:solidFill>
+                <a:latin typeface="Helvetica Neue"/>
+                <a:ea typeface="Helvetica Neue"/>
+                <a:cs typeface="Helvetica Neue"/>
+              </a:defRPr>
+            </a:lvl1pPr>
+            <a:lvl2pPr>
+              <a:defRPr sz="1800" b="0">
+                <a:solidFill>
+                  <a:srgbClr val="253F39"/>
+                </a:solidFill>
+                <a:latin typeface="Helvetica Neue"/>
+                <a:ea typeface="Helvetica Neue"/>
+                <a:cs typeface="Helvetica Neue"/>
+              </a:defRPr>
+            </a:lvl2pPr>
+            <a:lvl3pPr>
+              <a:defRPr sz="1800" b="0">
+                <a:solidFill>
+                  <a:srgbClr val="253F39"/>
+                </a:solidFill>
+                <a:latin typeface="Helvetica Neue"/>
+                <a:ea typeface="Helvetica Neue"/>
+                <a:cs typeface="Helvetica Neue"/>
+              </a:defRPr>
+            </a:lvl3pPr>
+            <a:lvl4pPr>
+              <a:defRPr sz="1800" b="0">
+                <a:solidFill>
+                  <a:srgbClr val="253F39"/>
+                </a:solidFill>
+                <a:latin typeface="Helvetica Neue"/>
+                <a:ea typeface="Helvetica Neue"/>
+                <a:cs typeface="Helvetica Neue"/>
+              </a:defRPr>
+            </a:lvl4pPr>
+            <a:lvl5pPr>
+              <a:defRPr sz="1800" b="0">
+                <a:solidFill>
+                  <a:srgbClr val="253F39"/>
+                </a:solidFill>
+                <a:latin typeface="Helvetica Neue"/>
+                <a:ea typeface="Helvetica Neue"/>
+                <a:cs typeface="Helvetica Neue"/>
+              </a:defRPr>
+            </a:lvl5pPr>
+            <a:lvl6pPr>
+              <a:defRPr sz="1800" b="0">
+                <a:solidFill>
+                  <a:srgbClr val="253F39"/>
+                </a:solidFill>
+                <a:latin typeface="Helvetica Neue"/>
+                <a:ea typeface="Helvetica Neue"/>
+                <a:cs typeface="Helvetica Neue"/>
+              </a:defRPr>
+            </a:lvl6pPr>
+            <a:lvl7pPr>
+              <a:defRPr sz="1800" b="0">
+                <a:solidFill>
+                  <a:srgbClr val="253F39"/>
+                </a:solidFill>
+                <a:latin typeface="Helvetica Neue"/>
+                <a:ea typeface="Helvetica Neue"/>
+                <a:cs typeface="Helvetica Neue"/>
+              </a:defRPr>
+            </a:lvl7pPr>
+            <a:lvl8pPr>
+              <a:defRPr sz="1800" b="0">
+                <a:solidFill>
+                  <a:srgbClr val="253F39"/>
+                </a:solidFill>
+                <a:latin typeface="Helvetica Neue"/>
+                <a:ea typeface="Helvetica Neue"/>
+                <a:cs typeface="Helvetica Neue"/>
+              </a:defRPr>
+            </a:lvl8pPr>
+            <a:lvl9pPr>
+              <a:defRPr sz="1800" b="0">
+                <a:solidFill>
+                  <a:srgbClr val="253F39"/>
+                </a:solidFill>
+                <a:latin typeface="Helvetica Neue"/>
+                <a:ea typeface="Helvetica Neue"/>
+                <a:cs typeface="Helvetica Neue"/>
+              </a:defRPr>
+            </a:lvl9pPr>
+          </a:lstStyle>
           <a:p xmlns:a="http://schemas.openxmlformats.org/drawingml/2006/main">
             <a:pPr>
-              <a:defRPr sz="1500" b="1">
-                <a:solidFill>
-                  <a:srgbClr val="174D46"/>
+              <a:buNone/>
+              <a:defRPr sz="1800" b="0">
+                <a:solidFill>
+                  <a:srgbClr val="253F39"/>
                 </a:solidFill>
                 <a:latin typeface="Helvetica Neue"/>
                 <a:ea typeface="Helvetica Neue"/>
@@ -1477,15 +2061,63 @@
               </a:defRPr>
             </a:pPr>
             <a:r>
-              <a:rPr sz="1500" b="1">
-                <a:solidFill>
-                  <a:srgbClr val="174D46"/>
+              <a:rPr sz="1800" b="0">
+                <a:solidFill>
+                  <a:srgbClr val="253F39"/>
                 </a:solidFill>
                 <a:latin typeface="Helvetica Neue"/>
                 <a:ea typeface="Helvetica Neue"/>
                 <a:cs typeface="Helvetica Neue"/>
               </a:rPr>
-              <a:t>WHY NOW</a:t>
+              <a:t>Search delivery records, ask for confirmation, then</a:t>
+            </a:r>
+          </a:p>
+          <a:p xmlns:a="http://schemas.openxmlformats.org/drawingml/2006/main">
+            <a:pPr>
+              <a:buNone/>
+              <a:defRPr sz="1800" b="0">
+                <a:solidFill>
+                  <a:srgbClr val="253F39"/>
+                </a:solidFill>
+                <a:latin typeface="Helvetica Neue"/>
+                <a:ea typeface="Helvetica Neue"/>
+                <a:cs typeface="Helvetica Neue"/>
+              </a:defRPr>
+            </a:pPr>
+            <a:r>
+              <a:rPr sz="1800" b="0">
+                <a:solidFill>
+                  <a:srgbClr val="253F39"/>
+                </a:solidFill>
+                <a:latin typeface="Helvetica Neue"/>
+                <a:ea typeface="Helvetica Neue"/>
+                <a:cs typeface="Helvetica Neue"/>
+              </a:rPr>
+              <a:t>reassess. Conflicts reopen human review.</a:t>
+            </a:r>
+          </a:p>
+          <a:p xmlns:a="http://schemas.openxmlformats.org/drawingml/2006/main">
+            <a:pPr>
+              <a:buNone/>
+              <a:defRPr sz="1800" b="0">
+                <a:solidFill>
+                  <a:srgbClr val="253F39"/>
+                </a:solidFill>
+                <a:latin typeface="Helvetica Neue"/>
+                <a:ea typeface="Helvetica Neue"/>
+                <a:cs typeface="Helvetica Neue"/>
+              </a:defRPr>
+            </a:pPr>
+            <a:r>
+              <a:rPr sz="1800" b="0">
+                <a:solidFill>
+                  <a:srgbClr val="253F39"/>
+                </a:solidFill>
+                <a:latin typeface="Helvetica Neue"/>
+                <a:ea typeface="Helvetica Neue"/>
+                <a:cs typeface="Helvetica Neue"/>
+              </a:rPr>
+              <a:t>Demo: 24 packets held, 18 outside this recall.</a:t>
             </a:r>
           </a:p>
         </p:txBody>
@@ -1506,8 +2138,8 @@
         </p:nvSpPr>
         <p:spPr>
           <a:xfrm xmlns:a="http://schemas.openxmlformats.org/drawingml/2006/main">
-            <a:off x="7239000" y="4114800"/>
-            <a:ext cx="4191000" cy="1047750"/>
+            <a:off x="457200" y="4476750"/>
+            <a:ext cx="6191250" cy="285750"/>
           </a:xfrm>
           <a:prstGeom xmlns:a="http://schemas.openxmlformats.org/drawingml/2006/main" prst="rect">
             <a:avLst/>
@@ -1518,15 +2150,117 @@
           </a:ln>
         </p:spPr>
         <p:txBody>
-          <a:bodyPr xmlns:a="http://schemas.openxmlformats.org/drawingml/2006/main">
+          <a:bodyPr xmlns:a="http://schemas.openxmlformats.org/drawingml/2006/main" lIns="0" tIns="0" rIns="0" bIns="0">
             <a:noAutofit/>
           </a:bodyPr>
-          <a:lstStyle xmlns:a="http://schemas.openxmlformats.org/drawingml/2006/main"/>
+          <a:lstStyle xmlns:a="http://schemas.openxmlformats.org/drawingml/2006/main">
+            <a:defPPr>
+              <a:defRPr sz="1575" b="1">
+                <a:solidFill>
+                  <a:srgbClr val="174D46"/>
+                </a:solidFill>
+                <a:latin typeface="Helvetica Neue"/>
+                <a:ea typeface="Helvetica Neue"/>
+                <a:cs typeface="Helvetica Neue"/>
+              </a:defRPr>
+            </a:defPPr>
+            <a:lvl1pPr>
+              <a:defRPr sz="1575" b="1">
+                <a:solidFill>
+                  <a:srgbClr val="174D46"/>
+                </a:solidFill>
+                <a:latin typeface="Helvetica Neue"/>
+                <a:ea typeface="Helvetica Neue"/>
+                <a:cs typeface="Helvetica Neue"/>
+              </a:defRPr>
+            </a:lvl1pPr>
+            <a:lvl2pPr>
+              <a:defRPr sz="1575" b="1">
+                <a:solidFill>
+                  <a:srgbClr val="174D46"/>
+                </a:solidFill>
+                <a:latin typeface="Helvetica Neue"/>
+                <a:ea typeface="Helvetica Neue"/>
+                <a:cs typeface="Helvetica Neue"/>
+              </a:defRPr>
+            </a:lvl2pPr>
+            <a:lvl3pPr>
+              <a:defRPr sz="1575" b="1">
+                <a:solidFill>
+                  <a:srgbClr val="174D46"/>
+                </a:solidFill>
+                <a:latin typeface="Helvetica Neue"/>
+                <a:ea typeface="Helvetica Neue"/>
+                <a:cs typeface="Helvetica Neue"/>
+              </a:defRPr>
+            </a:lvl3pPr>
+            <a:lvl4pPr>
+              <a:defRPr sz="1575" b="1">
+                <a:solidFill>
+                  <a:srgbClr val="174D46"/>
+                </a:solidFill>
+                <a:latin typeface="Helvetica Neue"/>
+                <a:ea typeface="Helvetica Neue"/>
+                <a:cs typeface="Helvetica Neue"/>
+              </a:defRPr>
+            </a:lvl4pPr>
+            <a:lvl5pPr>
+              <a:defRPr sz="1575" b="1">
+                <a:solidFill>
+                  <a:srgbClr val="174D46"/>
+                </a:solidFill>
+                <a:latin typeface="Helvetica Neue"/>
+                <a:ea typeface="Helvetica Neue"/>
+                <a:cs typeface="Helvetica Neue"/>
+              </a:defRPr>
+            </a:lvl5pPr>
+            <a:lvl6pPr>
+              <a:defRPr sz="1575" b="1">
+                <a:solidFill>
+                  <a:srgbClr val="174D46"/>
+                </a:solidFill>
+                <a:latin typeface="Helvetica Neue"/>
+                <a:ea typeface="Helvetica Neue"/>
+                <a:cs typeface="Helvetica Neue"/>
+              </a:defRPr>
+            </a:lvl6pPr>
+            <a:lvl7pPr>
+              <a:defRPr sz="1575" b="1">
+                <a:solidFill>
+                  <a:srgbClr val="174D46"/>
+                </a:solidFill>
+                <a:latin typeface="Helvetica Neue"/>
+                <a:ea typeface="Helvetica Neue"/>
+                <a:cs typeface="Helvetica Neue"/>
+              </a:defRPr>
+            </a:lvl7pPr>
+            <a:lvl8pPr>
+              <a:defRPr sz="1575" b="1">
+                <a:solidFill>
+                  <a:srgbClr val="174D46"/>
+                </a:solidFill>
+                <a:latin typeface="Helvetica Neue"/>
+                <a:ea typeface="Helvetica Neue"/>
+                <a:cs typeface="Helvetica Neue"/>
+              </a:defRPr>
+            </a:lvl8pPr>
+            <a:lvl9pPr>
+              <a:defRPr sz="1575" b="1">
+                <a:solidFill>
+                  <a:srgbClr val="174D46"/>
+                </a:solidFill>
+                <a:latin typeface="Helvetica Neue"/>
+                <a:ea typeface="Helvetica Neue"/>
+                <a:cs typeface="Helvetica Neue"/>
+              </a:defRPr>
+            </a:lvl9pPr>
+          </a:lstStyle>
           <a:p xmlns:a="http://schemas.openxmlformats.org/drawingml/2006/main">
             <a:pPr>
-              <a:defRPr sz="1875" b="0">
-                <a:solidFill>
-                  <a:srgbClr val="253F39"/>
+              <a:buNone/>
+              <a:defRPr sz="1575" b="1">
+                <a:solidFill>
+                  <a:srgbClr val="174D46"/>
                 </a:solidFill>
                 <a:latin typeface="Helvetica Neue"/>
                 <a:ea typeface="Helvetica Neue"/>
@@ -1534,61 +2268,15 @@
               </a:defRPr>
             </a:pPr>
             <a:r>
-              <a:rPr sz="1875" b="0">
-                <a:solidFill>
-                  <a:srgbClr val="253F39"/>
+              <a:rPr sz="1575" b="1">
+                <a:solidFill>
+                  <a:srgbClr val="174D46"/>
                 </a:solidFill>
                 <a:latin typeface="Helvetica Neue"/>
                 <a:ea typeface="Helvetica Neue"/>
                 <a:cs typeface="Helvetica Neue"/>
               </a:rPr>
-              <a:t>Public recall data and existing</a:t>
-            </a:r>
-          </a:p>
-          <a:p xmlns:a="http://schemas.openxmlformats.org/drawingml/2006/main">
-            <a:pPr>
-              <a:defRPr sz="1875" b="0">
-                <a:solidFill>
-                  <a:srgbClr val="253F39"/>
-                </a:solidFill>
-                <a:latin typeface="Helvetica Neue"/>
-                <a:ea typeface="Helvetica Neue"/>
-                <a:cs typeface="Helvetica Neue"/>
-              </a:defRPr>
-            </a:pPr>
-            <a:r>
-              <a:rPr sz="1875" b="0">
-                <a:solidFill>
-                  <a:srgbClr val="253F39"/>
-                </a:solidFill>
-                <a:latin typeface="Helvetica Neue"/>
-                <a:ea typeface="Helvetica Neue"/>
-                <a:cs typeface="Helvetica Neue"/>
-              </a:rPr>
-              <a:t>delivery exports make a focused</a:t>
-            </a:r>
-          </a:p>
-          <a:p xmlns:a="http://schemas.openxmlformats.org/drawingml/2006/main">
-            <a:pPr>
-              <a:defRPr sz="1875" b="0">
-                <a:solidFill>
-                  <a:srgbClr val="253F39"/>
-                </a:solidFill>
-                <a:latin typeface="Helvetica Neue"/>
-                <a:ea typeface="Helvetica Neue"/>
-                <a:cs typeface="Helvetica Neue"/>
-              </a:defRPr>
-            </a:pPr>
-            <a:r>
-              <a:rPr sz="1875" b="0">
-                <a:solidFill>
-                  <a:srgbClr val="253F39"/>
-                </a:solidFill>
-                <a:latin typeface="Helvetica Neue"/>
-                <a:ea typeface="Helvetica Neue"/>
-                <a:cs typeface="Helvetica Neue"/>
-              </a:rPr>
-              <a:t>pilot possible.</a:t>
+              <a:t>3. Data at the Core</a:t>
             </a:r>
           </a:p>
         </p:txBody>
@@ -1609,8 +2297,8 @@
         </p:nvSpPr>
         <p:spPr>
           <a:xfrm xmlns:a="http://schemas.openxmlformats.org/drawingml/2006/main">
-            <a:off x="647700" y="5362575"/>
-            <a:ext cx="10668000" cy="285750"/>
+            <a:off x="457200" y="4848225"/>
+            <a:ext cx="6238875" cy="990600"/>
           </a:xfrm>
           <a:prstGeom xmlns:a="http://schemas.openxmlformats.org/drawingml/2006/main" prst="rect">
             <a:avLst/>
@@ -1621,15 +2309,117 @@
           </a:ln>
         </p:spPr>
         <p:txBody>
-          <a:bodyPr xmlns:a="http://schemas.openxmlformats.org/drawingml/2006/main">
+          <a:bodyPr xmlns:a="http://schemas.openxmlformats.org/drawingml/2006/main" lIns="0" tIns="0" rIns="0" bIns="0">
             <a:noAutofit/>
           </a:bodyPr>
-          <a:lstStyle xmlns:a="http://schemas.openxmlformats.org/drawingml/2006/main"/>
+          <a:lstStyle xmlns:a="http://schemas.openxmlformats.org/drawingml/2006/main">
+            <a:defPPr>
+              <a:defRPr sz="1800" b="0">
+                <a:solidFill>
+                  <a:srgbClr val="253F39"/>
+                </a:solidFill>
+                <a:latin typeface="Helvetica Neue"/>
+                <a:ea typeface="Helvetica Neue"/>
+                <a:cs typeface="Helvetica Neue"/>
+              </a:defRPr>
+            </a:defPPr>
+            <a:lvl1pPr>
+              <a:defRPr sz="1800" b="0">
+                <a:solidFill>
+                  <a:srgbClr val="253F39"/>
+                </a:solidFill>
+                <a:latin typeface="Helvetica Neue"/>
+                <a:ea typeface="Helvetica Neue"/>
+                <a:cs typeface="Helvetica Neue"/>
+              </a:defRPr>
+            </a:lvl1pPr>
+            <a:lvl2pPr>
+              <a:defRPr sz="1800" b="0">
+                <a:solidFill>
+                  <a:srgbClr val="253F39"/>
+                </a:solidFill>
+                <a:latin typeface="Helvetica Neue"/>
+                <a:ea typeface="Helvetica Neue"/>
+                <a:cs typeface="Helvetica Neue"/>
+              </a:defRPr>
+            </a:lvl2pPr>
+            <a:lvl3pPr>
+              <a:defRPr sz="1800" b="0">
+                <a:solidFill>
+                  <a:srgbClr val="253F39"/>
+                </a:solidFill>
+                <a:latin typeface="Helvetica Neue"/>
+                <a:ea typeface="Helvetica Neue"/>
+                <a:cs typeface="Helvetica Neue"/>
+              </a:defRPr>
+            </a:lvl3pPr>
+            <a:lvl4pPr>
+              <a:defRPr sz="1800" b="0">
+                <a:solidFill>
+                  <a:srgbClr val="253F39"/>
+                </a:solidFill>
+                <a:latin typeface="Helvetica Neue"/>
+                <a:ea typeface="Helvetica Neue"/>
+                <a:cs typeface="Helvetica Neue"/>
+              </a:defRPr>
+            </a:lvl4pPr>
+            <a:lvl5pPr>
+              <a:defRPr sz="1800" b="0">
+                <a:solidFill>
+                  <a:srgbClr val="253F39"/>
+                </a:solidFill>
+                <a:latin typeface="Helvetica Neue"/>
+                <a:ea typeface="Helvetica Neue"/>
+                <a:cs typeface="Helvetica Neue"/>
+              </a:defRPr>
+            </a:lvl5pPr>
+            <a:lvl6pPr>
+              <a:defRPr sz="1800" b="0">
+                <a:solidFill>
+                  <a:srgbClr val="253F39"/>
+                </a:solidFill>
+                <a:latin typeface="Helvetica Neue"/>
+                <a:ea typeface="Helvetica Neue"/>
+                <a:cs typeface="Helvetica Neue"/>
+              </a:defRPr>
+            </a:lvl6pPr>
+            <a:lvl7pPr>
+              <a:defRPr sz="1800" b="0">
+                <a:solidFill>
+                  <a:srgbClr val="253F39"/>
+                </a:solidFill>
+                <a:latin typeface="Helvetica Neue"/>
+                <a:ea typeface="Helvetica Neue"/>
+                <a:cs typeface="Helvetica Neue"/>
+              </a:defRPr>
+            </a:lvl7pPr>
+            <a:lvl8pPr>
+              <a:defRPr sz="1800" b="0">
+                <a:solidFill>
+                  <a:srgbClr val="253F39"/>
+                </a:solidFill>
+                <a:latin typeface="Helvetica Neue"/>
+                <a:ea typeface="Helvetica Neue"/>
+                <a:cs typeface="Helvetica Neue"/>
+              </a:defRPr>
+            </a:lvl8pPr>
+            <a:lvl9pPr>
+              <a:defRPr sz="1800" b="0">
+                <a:solidFill>
+                  <a:srgbClr val="253F39"/>
+                </a:solidFill>
+                <a:latin typeface="Helvetica Neue"/>
+                <a:ea typeface="Helvetica Neue"/>
+                <a:cs typeface="Helvetica Neue"/>
+              </a:defRPr>
+            </a:lvl9pPr>
+          </a:lstStyle>
           <a:p xmlns:a="http://schemas.openxmlformats.org/drawingml/2006/main">
             <a:pPr>
-              <a:defRPr sz="1500" b="1">
-                <a:solidFill>
-                  <a:srgbClr val="174D46"/>
+              <a:buNone/>
+              <a:defRPr sz="1800" b="0">
+                <a:solidFill>
+                  <a:srgbClr val="253F39"/>
                 </a:solidFill>
                 <a:latin typeface="Helvetica Neue"/>
                 <a:ea typeface="Helvetica Neue"/>
@@ -1637,15 +2427,63 @@
               </a:defRPr>
             </a:pPr>
             <a:r>
-              <a:rPr sz="1500" b="1">
-                <a:solidFill>
-                  <a:srgbClr val="174D46"/>
+              <a:rPr sz="1800" b="0">
+                <a:solidFill>
+                  <a:srgbClr val="253F39"/>
                 </a:solidFill>
                 <a:latin typeface="Helvetica Neue"/>
                 <a:ea typeface="Helvetica Neue"/>
                 <a:cs typeface="Helvetica Neue"/>
               </a:rPr>
-              <a:t>FIRST USERS</a:t>
+              <a:t>Official recalls, stock and delivery documents.</a:t>
+            </a:r>
+          </a:p>
+          <a:p xmlns:a="http://schemas.openxmlformats.org/drawingml/2006/main">
+            <a:pPr>
+              <a:buNone/>
+              <a:defRPr sz="1800" b="0">
+                <a:solidFill>
+                  <a:srgbClr val="253F39"/>
+                </a:solidFill>
+                <a:latin typeface="Helvetica Neue"/>
+                <a:ea typeface="Helvetica Neue"/>
+                <a:cs typeface="Helvetica Neue"/>
+              </a:defRPr>
+            </a:pPr>
+            <a:r>
+              <a:rPr sz="1800" b="0">
+                <a:solidFill>
+                  <a:srgbClr val="253F39"/>
+                </a:solidFill>
+                <a:latin typeface="Helvetica Neue"/>
+                <a:ea typeface="Helvetica Neue"/>
+                <a:cs typeface="Helvetica Neue"/>
+              </a:rPr>
+              <a:t>PostgreSQL preserves versions and provenance.</a:t>
+            </a:r>
+          </a:p>
+          <a:p xmlns:a="http://schemas.openxmlformats.org/drawingml/2006/main">
+            <a:pPr>
+              <a:buNone/>
+              <a:defRPr sz="1800" b="0">
+                <a:solidFill>
+                  <a:srgbClr val="253F39"/>
+                </a:solidFill>
+                <a:latin typeface="Helvetica Neue"/>
+                <a:ea typeface="Helvetica Neue"/>
+                <a:cs typeface="Helvetica Neue"/>
+              </a:defRPr>
+            </a:pPr>
+            <a:r>
+              <a:rPr sz="1800" b="0">
+                <a:solidFill>
+                  <a:srgbClr val="253F39"/>
+                </a:solidFill>
+                <a:latin typeface="Helvetica Neue"/>
+                <a:ea typeface="Helvetica Neue"/>
+                <a:cs typeface="Helvetica Neue"/>
+              </a:rPr>
+              <a:t>New evidence triggers investigation.</a:t>
             </a:r>
           </a:p>
         </p:txBody>
@@ -1666,8 +2504,8 @@
         </p:nvSpPr>
         <p:spPr>
           <a:xfrm xmlns:a="http://schemas.openxmlformats.org/drawingml/2006/main">
-            <a:off x="647700" y="5743575"/>
-            <a:ext cx="10668000" cy="685800"/>
+            <a:off x="7239000" y="1571625"/>
+            <a:ext cx="4495800" cy="285750"/>
           </a:xfrm>
           <a:prstGeom xmlns:a="http://schemas.openxmlformats.org/drawingml/2006/main" prst="rect">
             <a:avLst/>
@@ -1678,15 +2516,117 @@
           </a:ln>
         </p:spPr>
         <p:txBody>
-          <a:bodyPr xmlns:a="http://schemas.openxmlformats.org/drawingml/2006/main">
+          <a:bodyPr xmlns:a="http://schemas.openxmlformats.org/drawingml/2006/main" lIns="0" tIns="0" rIns="0" bIns="0">
             <a:noAutofit/>
           </a:bodyPr>
-          <a:lstStyle xmlns:a="http://schemas.openxmlformats.org/drawingml/2006/main"/>
+          <a:lstStyle xmlns:a="http://schemas.openxmlformats.org/drawingml/2006/main">
+            <a:defPPr>
+              <a:defRPr sz="1575" b="1">
+                <a:solidFill>
+                  <a:srgbClr val="174D46"/>
+                </a:solidFill>
+                <a:latin typeface="Helvetica Neue"/>
+                <a:ea typeface="Helvetica Neue"/>
+                <a:cs typeface="Helvetica Neue"/>
+              </a:defRPr>
+            </a:defPPr>
+            <a:lvl1pPr>
+              <a:defRPr sz="1575" b="1">
+                <a:solidFill>
+                  <a:srgbClr val="174D46"/>
+                </a:solidFill>
+                <a:latin typeface="Helvetica Neue"/>
+                <a:ea typeface="Helvetica Neue"/>
+                <a:cs typeface="Helvetica Neue"/>
+              </a:defRPr>
+            </a:lvl1pPr>
+            <a:lvl2pPr>
+              <a:defRPr sz="1575" b="1">
+                <a:solidFill>
+                  <a:srgbClr val="174D46"/>
+                </a:solidFill>
+                <a:latin typeface="Helvetica Neue"/>
+                <a:ea typeface="Helvetica Neue"/>
+                <a:cs typeface="Helvetica Neue"/>
+              </a:defRPr>
+            </a:lvl2pPr>
+            <a:lvl3pPr>
+              <a:defRPr sz="1575" b="1">
+                <a:solidFill>
+                  <a:srgbClr val="174D46"/>
+                </a:solidFill>
+                <a:latin typeface="Helvetica Neue"/>
+                <a:ea typeface="Helvetica Neue"/>
+                <a:cs typeface="Helvetica Neue"/>
+              </a:defRPr>
+            </a:lvl3pPr>
+            <a:lvl4pPr>
+              <a:defRPr sz="1575" b="1">
+                <a:solidFill>
+                  <a:srgbClr val="174D46"/>
+                </a:solidFill>
+                <a:latin typeface="Helvetica Neue"/>
+                <a:ea typeface="Helvetica Neue"/>
+                <a:cs typeface="Helvetica Neue"/>
+              </a:defRPr>
+            </a:lvl4pPr>
+            <a:lvl5pPr>
+              <a:defRPr sz="1575" b="1">
+                <a:solidFill>
+                  <a:srgbClr val="174D46"/>
+                </a:solidFill>
+                <a:latin typeface="Helvetica Neue"/>
+                <a:ea typeface="Helvetica Neue"/>
+                <a:cs typeface="Helvetica Neue"/>
+              </a:defRPr>
+            </a:lvl5pPr>
+            <a:lvl6pPr>
+              <a:defRPr sz="1575" b="1">
+                <a:solidFill>
+                  <a:srgbClr val="174D46"/>
+                </a:solidFill>
+                <a:latin typeface="Helvetica Neue"/>
+                <a:ea typeface="Helvetica Neue"/>
+                <a:cs typeface="Helvetica Neue"/>
+              </a:defRPr>
+            </a:lvl6pPr>
+            <a:lvl7pPr>
+              <a:defRPr sz="1575" b="1">
+                <a:solidFill>
+                  <a:srgbClr val="174D46"/>
+                </a:solidFill>
+                <a:latin typeface="Helvetica Neue"/>
+                <a:ea typeface="Helvetica Neue"/>
+                <a:cs typeface="Helvetica Neue"/>
+              </a:defRPr>
+            </a:lvl7pPr>
+            <a:lvl8pPr>
+              <a:defRPr sz="1575" b="1">
+                <a:solidFill>
+                  <a:srgbClr val="174D46"/>
+                </a:solidFill>
+                <a:latin typeface="Helvetica Neue"/>
+                <a:ea typeface="Helvetica Neue"/>
+                <a:cs typeface="Helvetica Neue"/>
+              </a:defRPr>
+            </a:lvl8pPr>
+            <a:lvl9pPr>
+              <a:defRPr sz="1575" b="1">
+                <a:solidFill>
+                  <a:srgbClr val="174D46"/>
+                </a:solidFill>
+                <a:latin typeface="Helvetica Neue"/>
+                <a:ea typeface="Helvetica Neue"/>
+                <a:cs typeface="Helvetica Neue"/>
+              </a:defRPr>
+            </a:lvl9pPr>
+          </a:lstStyle>
           <a:p xmlns:a="http://schemas.openxmlformats.org/drawingml/2006/main">
             <a:pPr>
-              <a:defRPr sz="2025" b="0">
-                <a:solidFill>
-                  <a:srgbClr val="253F39"/>
+              <a:buNone/>
+              <a:defRPr sz="1575" b="1">
+                <a:solidFill>
+                  <a:srgbClr val="174D46"/>
                 </a:solidFill>
                 <a:latin typeface="Helvetica Neue"/>
                 <a:ea typeface="Helvetica Neue"/>
@@ -1694,20 +2634,968 @@
               </a:defRPr>
             </a:pPr>
             <a:r>
-              <a:rPr sz="2025" b="0">
-                <a:solidFill>
-                  <a:srgbClr val="253F39"/>
+              <a:rPr sz="1575" b="1">
+                <a:solidFill>
+                  <a:srgbClr val="174D46"/>
                 </a:solidFill>
                 <a:latin typeface="Helvetica Neue"/>
                 <a:ea typeface="Helvetica Neue"/>
                 <a:cs typeface="Helvetica Neue"/>
               </a:rPr>
-              <a:t>Supervised grocery pilots using historical cases.</a:t>
+              <a:t>4. Evidence It Works</a:t>
+            </a:r>
+          </a:p>
+        </p:txBody>
+      </p:sp>
+      <p:sp>
+        <p:nvSpPr>
+          <p:cNvPr id="11" name="">
+            <a:extLst xmlns:a="http://schemas.openxmlformats.org/drawingml/2006/main">
+              <a:ext uri="{FF2B5EF4-FFF2-40B4-BE49-F238E27FC236}">
+                <a16:creationId xmlns:a16="http://schemas.microsoft.com/office/drawing/2014/main" id="{D70FC394-09EA-4657-8EC8-3A599266E271}"/>
+              </a:ext>
+            </a:extLst>
+          </p:cNvPr>
+          <p:cNvSpPr>
+            <a:spLocks xmlns:a="http://schemas.openxmlformats.org/drawingml/2006/main" noGrp="1"/>
+          </p:cNvSpPr>
+          <p:nvPr/>
+        </p:nvSpPr>
+        <p:spPr>
+          <a:xfrm xmlns:a="http://schemas.openxmlformats.org/drawingml/2006/main">
+            <a:off x="7239000" y="1952625"/>
+            <a:ext cx="1905000" cy="619125"/>
+          </a:xfrm>
+          <a:prstGeom xmlns:a="http://schemas.openxmlformats.org/drawingml/2006/main" prst="rect">
+            <a:avLst/>
+          </a:prstGeom>
+          <a:noFill xmlns:a="http://schemas.openxmlformats.org/drawingml/2006/main"/>
+          <a:ln xmlns:a="http://schemas.openxmlformats.org/drawingml/2006/main" w="0">
+            <a:noFill/>
+          </a:ln>
+        </p:spPr>
+        <p:txBody>
+          <a:bodyPr xmlns:a="http://schemas.openxmlformats.org/drawingml/2006/main" lIns="0" tIns="0" rIns="0" bIns="0">
+            <a:noAutofit/>
+          </a:bodyPr>
+          <a:lstStyle xmlns:a="http://schemas.openxmlformats.org/drawingml/2006/main">
+            <a:defPPr>
+              <a:defRPr sz="3675" b="1">
+                <a:solidFill>
+                  <a:srgbClr val="527066"/>
+                </a:solidFill>
+                <a:latin typeface="Helvetica Neue"/>
+                <a:ea typeface="Helvetica Neue"/>
+                <a:cs typeface="Helvetica Neue"/>
+              </a:defRPr>
+            </a:defPPr>
+            <a:lvl1pPr>
+              <a:defRPr sz="3675" b="1">
+                <a:solidFill>
+                  <a:srgbClr val="527066"/>
+                </a:solidFill>
+                <a:latin typeface="Helvetica Neue"/>
+                <a:ea typeface="Helvetica Neue"/>
+                <a:cs typeface="Helvetica Neue"/>
+              </a:defRPr>
+            </a:lvl1pPr>
+            <a:lvl2pPr>
+              <a:defRPr sz="3675" b="1">
+                <a:solidFill>
+                  <a:srgbClr val="527066"/>
+                </a:solidFill>
+                <a:latin typeface="Helvetica Neue"/>
+                <a:ea typeface="Helvetica Neue"/>
+                <a:cs typeface="Helvetica Neue"/>
+              </a:defRPr>
+            </a:lvl2pPr>
+            <a:lvl3pPr>
+              <a:defRPr sz="3675" b="1">
+                <a:solidFill>
+                  <a:srgbClr val="527066"/>
+                </a:solidFill>
+                <a:latin typeface="Helvetica Neue"/>
+                <a:ea typeface="Helvetica Neue"/>
+                <a:cs typeface="Helvetica Neue"/>
+              </a:defRPr>
+            </a:lvl3pPr>
+            <a:lvl4pPr>
+              <a:defRPr sz="3675" b="1">
+                <a:solidFill>
+                  <a:srgbClr val="527066"/>
+                </a:solidFill>
+                <a:latin typeface="Helvetica Neue"/>
+                <a:ea typeface="Helvetica Neue"/>
+                <a:cs typeface="Helvetica Neue"/>
+              </a:defRPr>
+            </a:lvl4pPr>
+            <a:lvl5pPr>
+              <a:defRPr sz="3675" b="1">
+                <a:solidFill>
+                  <a:srgbClr val="527066"/>
+                </a:solidFill>
+                <a:latin typeface="Helvetica Neue"/>
+                <a:ea typeface="Helvetica Neue"/>
+                <a:cs typeface="Helvetica Neue"/>
+              </a:defRPr>
+            </a:lvl5pPr>
+            <a:lvl6pPr>
+              <a:defRPr sz="3675" b="1">
+                <a:solidFill>
+                  <a:srgbClr val="527066"/>
+                </a:solidFill>
+                <a:latin typeface="Helvetica Neue"/>
+                <a:ea typeface="Helvetica Neue"/>
+                <a:cs typeface="Helvetica Neue"/>
+              </a:defRPr>
+            </a:lvl6pPr>
+            <a:lvl7pPr>
+              <a:defRPr sz="3675" b="1">
+                <a:solidFill>
+                  <a:srgbClr val="527066"/>
+                </a:solidFill>
+                <a:latin typeface="Helvetica Neue"/>
+                <a:ea typeface="Helvetica Neue"/>
+                <a:cs typeface="Helvetica Neue"/>
+              </a:defRPr>
+            </a:lvl7pPr>
+            <a:lvl8pPr>
+              <a:defRPr sz="3675" b="1">
+                <a:solidFill>
+                  <a:srgbClr val="527066"/>
+                </a:solidFill>
+                <a:latin typeface="Helvetica Neue"/>
+                <a:ea typeface="Helvetica Neue"/>
+                <a:cs typeface="Helvetica Neue"/>
+              </a:defRPr>
+            </a:lvl8pPr>
+            <a:lvl9pPr>
+              <a:defRPr sz="3675" b="1">
+                <a:solidFill>
+                  <a:srgbClr val="527066"/>
+                </a:solidFill>
+                <a:latin typeface="Helvetica Neue"/>
+                <a:ea typeface="Helvetica Neue"/>
+                <a:cs typeface="Helvetica Neue"/>
+              </a:defRPr>
+            </a:lvl9pPr>
+          </a:lstStyle>
+          <a:p xmlns:a="http://schemas.openxmlformats.org/drawingml/2006/main">
+            <a:pPr>
+              <a:defRPr sz="3675" b="1">
+                <a:solidFill>
+                  <a:srgbClr val="527066"/>
+                </a:solidFill>
+                <a:latin typeface="Helvetica Neue"/>
+                <a:ea typeface="Helvetica Neue"/>
+                <a:cs typeface="Helvetica Neue"/>
+              </a:defRPr>
+            </a:pPr>
+            <a:r>
+              <a:rPr sz="3675" b="1">
+                <a:solidFill>
+                  <a:srgbClr val="527066"/>
+                </a:solidFill>
+                <a:latin typeface="Helvetica Neue"/>
+                <a:ea typeface="Helvetica Neue"/>
+                <a:cs typeface="Helvetica Neue"/>
+              </a:rPr>
+              <a:t>6/12</a:t>
+            </a:r>
+          </a:p>
+        </p:txBody>
+      </p:sp>
+      <p:sp>
+        <p:nvSpPr>
+          <p:cNvPr id="12" name="">
+            <a:extLst xmlns:a="http://schemas.openxmlformats.org/drawingml/2006/main">
+              <a:ext uri="{FF2B5EF4-FFF2-40B4-BE49-F238E27FC236}">
+                <a16:creationId xmlns:a16="http://schemas.microsoft.com/office/drawing/2014/main" id="{E8ADAD5D-911F-40A1-9488-B40902E0ECFB}"/>
+              </a:ext>
+            </a:extLst>
+          </p:cNvPr>
+          <p:cNvSpPr>
+            <a:spLocks xmlns:a="http://schemas.openxmlformats.org/drawingml/2006/main" noGrp="1"/>
+          </p:cNvSpPr>
+          <p:nvPr/>
+        </p:nvSpPr>
+        <p:spPr>
+          <a:xfrm xmlns:a="http://schemas.openxmlformats.org/drawingml/2006/main">
+            <a:off x="9525000" y="1952625"/>
+            <a:ext cx="2209800" cy="619125"/>
+          </a:xfrm>
+          <a:prstGeom xmlns:a="http://schemas.openxmlformats.org/drawingml/2006/main" prst="rect">
+            <a:avLst/>
+          </a:prstGeom>
+          <a:noFill xmlns:a="http://schemas.openxmlformats.org/drawingml/2006/main"/>
+          <a:ln xmlns:a="http://schemas.openxmlformats.org/drawingml/2006/main" w="0">
+            <a:noFill/>
+          </a:ln>
+        </p:spPr>
+        <p:txBody>
+          <a:bodyPr xmlns:a="http://schemas.openxmlformats.org/drawingml/2006/main" lIns="0" tIns="0" rIns="0" bIns="0">
+            <a:noAutofit/>
+          </a:bodyPr>
+          <a:lstStyle xmlns:a="http://schemas.openxmlformats.org/drawingml/2006/main">
+            <a:defPPr>
+              <a:defRPr sz="3675" b="1">
+                <a:solidFill>
+                  <a:srgbClr val="174D46"/>
+                </a:solidFill>
+                <a:latin typeface="Helvetica Neue"/>
+                <a:ea typeface="Helvetica Neue"/>
+                <a:cs typeface="Helvetica Neue"/>
+              </a:defRPr>
+            </a:defPPr>
+            <a:lvl1pPr>
+              <a:defRPr sz="3675" b="1">
+                <a:solidFill>
+                  <a:srgbClr val="174D46"/>
+                </a:solidFill>
+                <a:latin typeface="Helvetica Neue"/>
+                <a:ea typeface="Helvetica Neue"/>
+                <a:cs typeface="Helvetica Neue"/>
+              </a:defRPr>
+            </a:lvl1pPr>
+            <a:lvl2pPr>
+              <a:defRPr sz="3675" b="1">
+                <a:solidFill>
+                  <a:srgbClr val="174D46"/>
+                </a:solidFill>
+                <a:latin typeface="Helvetica Neue"/>
+                <a:ea typeface="Helvetica Neue"/>
+                <a:cs typeface="Helvetica Neue"/>
+              </a:defRPr>
+            </a:lvl2pPr>
+            <a:lvl3pPr>
+              <a:defRPr sz="3675" b="1">
+                <a:solidFill>
+                  <a:srgbClr val="174D46"/>
+                </a:solidFill>
+                <a:latin typeface="Helvetica Neue"/>
+                <a:ea typeface="Helvetica Neue"/>
+                <a:cs typeface="Helvetica Neue"/>
+              </a:defRPr>
+            </a:lvl3pPr>
+            <a:lvl4pPr>
+              <a:defRPr sz="3675" b="1">
+                <a:solidFill>
+                  <a:srgbClr val="174D46"/>
+                </a:solidFill>
+                <a:latin typeface="Helvetica Neue"/>
+                <a:ea typeface="Helvetica Neue"/>
+                <a:cs typeface="Helvetica Neue"/>
+              </a:defRPr>
+            </a:lvl4pPr>
+            <a:lvl5pPr>
+              <a:defRPr sz="3675" b="1">
+                <a:solidFill>
+                  <a:srgbClr val="174D46"/>
+                </a:solidFill>
+                <a:latin typeface="Helvetica Neue"/>
+                <a:ea typeface="Helvetica Neue"/>
+                <a:cs typeface="Helvetica Neue"/>
+              </a:defRPr>
+            </a:lvl5pPr>
+            <a:lvl6pPr>
+              <a:defRPr sz="3675" b="1">
+                <a:solidFill>
+                  <a:srgbClr val="174D46"/>
+                </a:solidFill>
+                <a:latin typeface="Helvetica Neue"/>
+                <a:ea typeface="Helvetica Neue"/>
+                <a:cs typeface="Helvetica Neue"/>
+              </a:defRPr>
+            </a:lvl6pPr>
+            <a:lvl7pPr>
+              <a:defRPr sz="3675" b="1">
+                <a:solidFill>
+                  <a:srgbClr val="174D46"/>
+                </a:solidFill>
+                <a:latin typeface="Helvetica Neue"/>
+                <a:ea typeface="Helvetica Neue"/>
+                <a:cs typeface="Helvetica Neue"/>
+              </a:defRPr>
+            </a:lvl7pPr>
+            <a:lvl8pPr>
+              <a:defRPr sz="3675" b="1">
+                <a:solidFill>
+                  <a:srgbClr val="174D46"/>
+                </a:solidFill>
+                <a:latin typeface="Helvetica Neue"/>
+                <a:ea typeface="Helvetica Neue"/>
+                <a:cs typeface="Helvetica Neue"/>
+              </a:defRPr>
+            </a:lvl8pPr>
+            <a:lvl9pPr>
+              <a:defRPr sz="3675" b="1">
+                <a:solidFill>
+                  <a:srgbClr val="174D46"/>
+                </a:solidFill>
+                <a:latin typeface="Helvetica Neue"/>
+                <a:ea typeface="Helvetica Neue"/>
+                <a:cs typeface="Helvetica Neue"/>
+              </a:defRPr>
+            </a:lvl9pPr>
+          </a:lstStyle>
+          <a:p xmlns:a="http://schemas.openxmlformats.org/drawingml/2006/main">
+            <a:pPr>
+              <a:defRPr sz="3675" b="1">
+                <a:solidFill>
+                  <a:srgbClr val="174D46"/>
+                </a:solidFill>
+                <a:latin typeface="Helvetica Neue"/>
+                <a:ea typeface="Helvetica Neue"/>
+                <a:cs typeface="Helvetica Neue"/>
+              </a:defRPr>
+            </a:pPr>
+            <a:r>
+              <a:rPr sz="3675" b="1">
+                <a:solidFill>
+                  <a:srgbClr val="174D46"/>
+                </a:solidFill>
+                <a:latin typeface="Helvetica Neue"/>
+                <a:ea typeface="Helvetica Neue"/>
+                <a:cs typeface="Helvetica Neue"/>
+              </a:rPr>
+              <a:t>12/12</a:t>
+            </a:r>
+          </a:p>
+        </p:txBody>
+      </p:sp>
+      <p:sp>
+        <p:nvSpPr>
+          <p:cNvPr id="13" name="">
+            <a:extLst xmlns:a="http://schemas.openxmlformats.org/drawingml/2006/main">
+              <a:ext uri="{FF2B5EF4-FFF2-40B4-BE49-F238E27FC236}">
+                <a16:creationId xmlns:a16="http://schemas.microsoft.com/office/drawing/2014/main" id="{39474FD9-17B9-4507-B125-729650E7F1E5}"/>
+              </a:ext>
+            </a:extLst>
+          </p:cNvPr>
+          <p:cNvSpPr>
+            <a:spLocks xmlns:a="http://schemas.openxmlformats.org/drawingml/2006/main" noGrp="1"/>
+          </p:cNvSpPr>
+          <p:nvPr/>
+        </p:nvSpPr>
+        <p:spPr>
+          <a:xfrm xmlns:a="http://schemas.openxmlformats.org/drawingml/2006/main">
+            <a:off x="7239000" y="2600325"/>
+            <a:ext cx="2095500" cy="295275"/>
+          </a:xfrm>
+          <a:prstGeom xmlns:a="http://schemas.openxmlformats.org/drawingml/2006/main" prst="rect">
+            <a:avLst/>
+          </a:prstGeom>
+          <a:noFill xmlns:a="http://schemas.openxmlformats.org/drawingml/2006/main"/>
+          <a:ln xmlns:a="http://schemas.openxmlformats.org/drawingml/2006/main" w="0">
+            <a:noFill/>
+          </a:ln>
+        </p:spPr>
+        <p:txBody>
+          <a:bodyPr xmlns:a="http://schemas.openxmlformats.org/drawingml/2006/main" lIns="0" tIns="0" rIns="0" bIns="0">
+            <a:noAutofit/>
+          </a:bodyPr>
+          <a:lstStyle xmlns:a="http://schemas.openxmlformats.org/drawingml/2006/main">
+            <a:defPPr>
+              <a:defRPr sz="1725" b="0">
+                <a:solidFill>
+                  <a:srgbClr val="253F39"/>
+                </a:solidFill>
+                <a:latin typeface="Helvetica Neue"/>
+                <a:ea typeface="Helvetica Neue"/>
+                <a:cs typeface="Helvetica Neue"/>
+              </a:defRPr>
+            </a:defPPr>
+            <a:lvl1pPr>
+              <a:defRPr sz="1725" b="0">
+                <a:solidFill>
+                  <a:srgbClr val="253F39"/>
+                </a:solidFill>
+                <a:latin typeface="Helvetica Neue"/>
+                <a:ea typeface="Helvetica Neue"/>
+                <a:cs typeface="Helvetica Neue"/>
+              </a:defRPr>
+            </a:lvl1pPr>
+            <a:lvl2pPr>
+              <a:defRPr sz="1725" b="0">
+                <a:solidFill>
+                  <a:srgbClr val="253F39"/>
+                </a:solidFill>
+                <a:latin typeface="Helvetica Neue"/>
+                <a:ea typeface="Helvetica Neue"/>
+                <a:cs typeface="Helvetica Neue"/>
+              </a:defRPr>
+            </a:lvl2pPr>
+            <a:lvl3pPr>
+              <a:defRPr sz="1725" b="0">
+                <a:solidFill>
+                  <a:srgbClr val="253F39"/>
+                </a:solidFill>
+                <a:latin typeface="Helvetica Neue"/>
+                <a:ea typeface="Helvetica Neue"/>
+                <a:cs typeface="Helvetica Neue"/>
+              </a:defRPr>
+            </a:lvl3pPr>
+            <a:lvl4pPr>
+              <a:defRPr sz="1725" b="0">
+                <a:solidFill>
+                  <a:srgbClr val="253F39"/>
+                </a:solidFill>
+                <a:latin typeface="Helvetica Neue"/>
+                <a:ea typeface="Helvetica Neue"/>
+                <a:cs typeface="Helvetica Neue"/>
+              </a:defRPr>
+            </a:lvl4pPr>
+            <a:lvl5pPr>
+              <a:defRPr sz="1725" b="0">
+                <a:solidFill>
+                  <a:srgbClr val="253F39"/>
+                </a:solidFill>
+                <a:latin typeface="Helvetica Neue"/>
+                <a:ea typeface="Helvetica Neue"/>
+                <a:cs typeface="Helvetica Neue"/>
+              </a:defRPr>
+            </a:lvl5pPr>
+            <a:lvl6pPr>
+              <a:defRPr sz="1725" b="0">
+                <a:solidFill>
+                  <a:srgbClr val="253F39"/>
+                </a:solidFill>
+                <a:latin typeface="Helvetica Neue"/>
+                <a:ea typeface="Helvetica Neue"/>
+                <a:cs typeface="Helvetica Neue"/>
+              </a:defRPr>
+            </a:lvl6pPr>
+            <a:lvl7pPr>
+              <a:defRPr sz="1725" b="0">
+                <a:solidFill>
+                  <a:srgbClr val="253F39"/>
+                </a:solidFill>
+                <a:latin typeface="Helvetica Neue"/>
+                <a:ea typeface="Helvetica Neue"/>
+                <a:cs typeface="Helvetica Neue"/>
+              </a:defRPr>
+            </a:lvl7pPr>
+            <a:lvl8pPr>
+              <a:defRPr sz="1725" b="0">
+                <a:solidFill>
+                  <a:srgbClr val="253F39"/>
+                </a:solidFill>
+                <a:latin typeface="Helvetica Neue"/>
+                <a:ea typeface="Helvetica Neue"/>
+                <a:cs typeface="Helvetica Neue"/>
+              </a:defRPr>
+            </a:lvl8pPr>
+            <a:lvl9pPr>
+              <a:defRPr sz="1725" b="0">
+                <a:solidFill>
+                  <a:srgbClr val="253F39"/>
+                </a:solidFill>
+                <a:latin typeface="Helvetica Neue"/>
+                <a:ea typeface="Helvetica Neue"/>
+                <a:cs typeface="Helvetica Neue"/>
+              </a:defRPr>
+            </a:lvl9pPr>
+          </a:lstStyle>
+          <a:p xmlns:a="http://schemas.openxmlformats.org/drawingml/2006/main">
+            <a:pPr>
+              <a:defRPr sz="1725" b="0">
+                <a:solidFill>
+                  <a:srgbClr val="253F39"/>
+                </a:solidFill>
+                <a:latin typeface="Helvetica Neue"/>
+                <a:ea typeface="Helvetica Neue"/>
+                <a:cs typeface="Helvetica Neue"/>
+              </a:defRPr>
+            </a:pPr>
+            <a:r>
+              <a:rPr sz="1725" b="0">
+                <a:solidFill>
+                  <a:srgbClr val="253F39"/>
+                </a:solidFill>
+                <a:latin typeface="Helvetica Neue"/>
+                <a:ea typeface="Helvetica Neue"/>
+                <a:cs typeface="Helvetica Neue"/>
+              </a:rPr>
+              <a:t>Baseline</a:t>
+            </a:r>
+          </a:p>
+        </p:txBody>
+      </p:sp>
+      <p:sp>
+        <p:nvSpPr>
+          <p:cNvPr id="14" name="">
+            <a:extLst xmlns:a="http://schemas.openxmlformats.org/drawingml/2006/main">
+              <a:ext uri="{FF2B5EF4-FFF2-40B4-BE49-F238E27FC236}">
+                <a16:creationId xmlns:a16="http://schemas.microsoft.com/office/drawing/2014/main" id="{9CCABFEB-0CC6-4756-B038-476669E25557}"/>
+              </a:ext>
+            </a:extLst>
+          </p:cNvPr>
+          <p:cNvSpPr>
+            <a:spLocks xmlns:a="http://schemas.openxmlformats.org/drawingml/2006/main" noGrp="1"/>
+          </p:cNvSpPr>
+          <p:nvPr/>
+        </p:nvSpPr>
+        <p:spPr>
+          <a:xfrm xmlns:a="http://schemas.openxmlformats.org/drawingml/2006/main">
+            <a:off x="9525000" y="2600325"/>
+            <a:ext cx="2209800" cy="295275"/>
+          </a:xfrm>
+          <a:prstGeom xmlns:a="http://schemas.openxmlformats.org/drawingml/2006/main" prst="rect">
+            <a:avLst/>
+          </a:prstGeom>
+          <a:noFill xmlns:a="http://schemas.openxmlformats.org/drawingml/2006/main"/>
+          <a:ln xmlns:a="http://schemas.openxmlformats.org/drawingml/2006/main" w="0">
+            <a:noFill/>
+          </a:ln>
+        </p:spPr>
+        <p:txBody>
+          <a:bodyPr xmlns:a="http://schemas.openxmlformats.org/drawingml/2006/main" lIns="0" tIns="0" rIns="0" bIns="0">
+            <a:noAutofit/>
+          </a:bodyPr>
+          <a:lstStyle xmlns:a="http://schemas.openxmlformats.org/drawingml/2006/main">
+            <a:defPPr>
+              <a:defRPr sz="1725" b="0">
+                <a:solidFill>
+                  <a:srgbClr val="253F39"/>
+                </a:solidFill>
+                <a:latin typeface="Helvetica Neue"/>
+                <a:ea typeface="Helvetica Neue"/>
+                <a:cs typeface="Helvetica Neue"/>
+              </a:defRPr>
+            </a:defPPr>
+            <a:lvl1pPr>
+              <a:defRPr sz="1725" b="0">
+                <a:solidFill>
+                  <a:srgbClr val="253F39"/>
+                </a:solidFill>
+                <a:latin typeface="Helvetica Neue"/>
+                <a:ea typeface="Helvetica Neue"/>
+                <a:cs typeface="Helvetica Neue"/>
+              </a:defRPr>
+            </a:lvl1pPr>
+            <a:lvl2pPr>
+              <a:defRPr sz="1725" b="0">
+                <a:solidFill>
+                  <a:srgbClr val="253F39"/>
+                </a:solidFill>
+                <a:latin typeface="Helvetica Neue"/>
+                <a:ea typeface="Helvetica Neue"/>
+                <a:cs typeface="Helvetica Neue"/>
+              </a:defRPr>
+            </a:lvl2pPr>
+            <a:lvl3pPr>
+              <a:defRPr sz="1725" b="0">
+                <a:solidFill>
+                  <a:srgbClr val="253F39"/>
+                </a:solidFill>
+                <a:latin typeface="Helvetica Neue"/>
+                <a:ea typeface="Helvetica Neue"/>
+                <a:cs typeface="Helvetica Neue"/>
+              </a:defRPr>
+            </a:lvl3pPr>
+            <a:lvl4pPr>
+              <a:defRPr sz="1725" b="0">
+                <a:solidFill>
+                  <a:srgbClr val="253F39"/>
+                </a:solidFill>
+                <a:latin typeface="Helvetica Neue"/>
+                <a:ea typeface="Helvetica Neue"/>
+                <a:cs typeface="Helvetica Neue"/>
+              </a:defRPr>
+            </a:lvl4pPr>
+            <a:lvl5pPr>
+              <a:defRPr sz="1725" b="0">
+                <a:solidFill>
+                  <a:srgbClr val="253F39"/>
+                </a:solidFill>
+                <a:latin typeface="Helvetica Neue"/>
+                <a:ea typeface="Helvetica Neue"/>
+                <a:cs typeface="Helvetica Neue"/>
+              </a:defRPr>
+            </a:lvl5pPr>
+            <a:lvl6pPr>
+              <a:defRPr sz="1725" b="0">
+                <a:solidFill>
+                  <a:srgbClr val="253F39"/>
+                </a:solidFill>
+                <a:latin typeface="Helvetica Neue"/>
+                <a:ea typeface="Helvetica Neue"/>
+                <a:cs typeface="Helvetica Neue"/>
+              </a:defRPr>
+            </a:lvl6pPr>
+            <a:lvl7pPr>
+              <a:defRPr sz="1725" b="0">
+                <a:solidFill>
+                  <a:srgbClr val="253F39"/>
+                </a:solidFill>
+                <a:latin typeface="Helvetica Neue"/>
+                <a:ea typeface="Helvetica Neue"/>
+                <a:cs typeface="Helvetica Neue"/>
+              </a:defRPr>
+            </a:lvl7pPr>
+            <a:lvl8pPr>
+              <a:defRPr sz="1725" b="0">
+                <a:solidFill>
+                  <a:srgbClr val="253F39"/>
+                </a:solidFill>
+                <a:latin typeface="Helvetica Neue"/>
+                <a:ea typeface="Helvetica Neue"/>
+                <a:cs typeface="Helvetica Neue"/>
+              </a:defRPr>
+            </a:lvl8pPr>
+            <a:lvl9pPr>
+              <a:defRPr sz="1725" b="0">
+                <a:solidFill>
+                  <a:srgbClr val="253F39"/>
+                </a:solidFill>
+                <a:latin typeface="Helvetica Neue"/>
+                <a:ea typeface="Helvetica Neue"/>
+                <a:cs typeface="Helvetica Neue"/>
+              </a:defRPr>
+            </a:lvl9pPr>
+          </a:lstStyle>
+          <a:p xmlns:a="http://schemas.openxmlformats.org/drawingml/2006/main">
+            <a:pPr>
+              <a:defRPr sz="1725" b="0">
+                <a:solidFill>
+                  <a:srgbClr val="253F39"/>
+                </a:solidFill>
+                <a:latin typeface="Helvetica Neue"/>
+                <a:ea typeface="Helvetica Neue"/>
+                <a:cs typeface="Helvetica Neue"/>
+              </a:defRPr>
+            </a:pPr>
+            <a:r>
+              <a:rPr sz="1725" b="0">
+                <a:solidFill>
+                  <a:srgbClr val="253F39"/>
+                </a:solidFill>
+                <a:latin typeface="Helvetica Neue"/>
+                <a:ea typeface="Helvetica Neue"/>
+                <a:cs typeface="Helvetica Neue"/>
+              </a:rPr>
+              <a:t>Adaptive investigator</a:t>
+            </a:r>
+          </a:p>
+        </p:txBody>
+      </p:sp>
+      <p:sp>
+        <p:nvSpPr>
+          <p:cNvPr id="15" name="">
+            <a:extLst xmlns:a="http://schemas.openxmlformats.org/drawingml/2006/main">
+              <a:ext uri="{FF2B5EF4-FFF2-40B4-BE49-F238E27FC236}">
+                <a16:creationId xmlns:a16="http://schemas.microsoft.com/office/drawing/2014/main" id="{D5AB2586-6BB8-469C-9D91-C685073AF515}"/>
+              </a:ext>
+            </a:extLst>
+          </p:cNvPr>
+          <p:cNvSpPr>
+            <a:spLocks xmlns:a="http://schemas.openxmlformats.org/drawingml/2006/main" noGrp="1"/>
+          </p:cNvSpPr>
+          <p:nvPr/>
+        </p:nvSpPr>
+        <p:spPr>
+          <a:xfrm xmlns:a="http://schemas.openxmlformats.org/drawingml/2006/main">
+            <a:off x="7239000" y="2981325"/>
+            <a:ext cx="4495800" cy="295275"/>
+          </a:xfrm>
+          <a:prstGeom xmlns:a="http://schemas.openxmlformats.org/drawingml/2006/main" prst="rect">
+            <a:avLst/>
+          </a:prstGeom>
+          <a:noFill xmlns:a="http://schemas.openxmlformats.org/drawingml/2006/main"/>
+          <a:ln xmlns:a="http://schemas.openxmlformats.org/drawingml/2006/main" w="0">
+            <a:noFill/>
+          </a:ln>
+        </p:spPr>
+        <p:txBody>
+          <a:bodyPr xmlns:a="http://schemas.openxmlformats.org/drawingml/2006/main" lIns="0" tIns="0" rIns="0" bIns="0">
+            <a:noAutofit/>
+          </a:bodyPr>
+          <a:lstStyle xmlns:a="http://schemas.openxmlformats.org/drawingml/2006/main">
+            <a:defPPr>
+              <a:defRPr sz="1725" b="1">
+                <a:solidFill>
+                  <a:srgbClr val="253F39"/>
+                </a:solidFill>
+                <a:latin typeface="Helvetica Neue"/>
+                <a:ea typeface="Helvetica Neue"/>
+                <a:cs typeface="Helvetica Neue"/>
+              </a:defRPr>
+            </a:defPPr>
+            <a:lvl1pPr>
+              <a:defRPr sz="1725" b="1">
+                <a:solidFill>
+                  <a:srgbClr val="253F39"/>
+                </a:solidFill>
+                <a:latin typeface="Helvetica Neue"/>
+                <a:ea typeface="Helvetica Neue"/>
+                <a:cs typeface="Helvetica Neue"/>
+              </a:defRPr>
+            </a:lvl1pPr>
+            <a:lvl2pPr>
+              <a:defRPr sz="1725" b="1">
+                <a:solidFill>
+                  <a:srgbClr val="253F39"/>
+                </a:solidFill>
+                <a:latin typeface="Helvetica Neue"/>
+                <a:ea typeface="Helvetica Neue"/>
+                <a:cs typeface="Helvetica Neue"/>
+              </a:defRPr>
+            </a:lvl2pPr>
+            <a:lvl3pPr>
+              <a:defRPr sz="1725" b="1">
+                <a:solidFill>
+                  <a:srgbClr val="253F39"/>
+                </a:solidFill>
+                <a:latin typeface="Helvetica Neue"/>
+                <a:ea typeface="Helvetica Neue"/>
+                <a:cs typeface="Helvetica Neue"/>
+              </a:defRPr>
+            </a:lvl3pPr>
+            <a:lvl4pPr>
+              <a:defRPr sz="1725" b="1">
+                <a:solidFill>
+                  <a:srgbClr val="253F39"/>
+                </a:solidFill>
+                <a:latin typeface="Helvetica Neue"/>
+                <a:ea typeface="Helvetica Neue"/>
+                <a:cs typeface="Helvetica Neue"/>
+              </a:defRPr>
+            </a:lvl4pPr>
+            <a:lvl5pPr>
+              <a:defRPr sz="1725" b="1">
+                <a:solidFill>
+                  <a:srgbClr val="253F39"/>
+                </a:solidFill>
+                <a:latin typeface="Helvetica Neue"/>
+                <a:ea typeface="Helvetica Neue"/>
+                <a:cs typeface="Helvetica Neue"/>
+              </a:defRPr>
+            </a:lvl5pPr>
+            <a:lvl6pPr>
+              <a:defRPr sz="1725" b="1">
+                <a:solidFill>
+                  <a:srgbClr val="253F39"/>
+                </a:solidFill>
+                <a:latin typeface="Helvetica Neue"/>
+                <a:ea typeface="Helvetica Neue"/>
+                <a:cs typeface="Helvetica Neue"/>
+              </a:defRPr>
+            </a:lvl6pPr>
+            <a:lvl7pPr>
+              <a:defRPr sz="1725" b="1">
+                <a:solidFill>
+                  <a:srgbClr val="253F39"/>
+                </a:solidFill>
+                <a:latin typeface="Helvetica Neue"/>
+                <a:ea typeface="Helvetica Neue"/>
+                <a:cs typeface="Helvetica Neue"/>
+              </a:defRPr>
+            </a:lvl7pPr>
+            <a:lvl8pPr>
+              <a:defRPr sz="1725" b="1">
+                <a:solidFill>
+                  <a:srgbClr val="253F39"/>
+                </a:solidFill>
+                <a:latin typeface="Helvetica Neue"/>
+                <a:ea typeface="Helvetica Neue"/>
+                <a:cs typeface="Helvetica Neue"/>
+              </a:defRPr>
+            </a:lvl8pPr>
+            <a:lvl9pPr>
+              <a:defRPr sz="1725" b="1">
+                <a:solidFill>
+                  <a:srgbClr val="253F39"/>
+                </a:solidFill>
+                <a:latin typeface="Helvetica Neue"/>
+                <a:ea typeface="Helvetica Neue"/>
+                <a:cs typeface="Helvetica Neue"/>
+              </a:defRPr>
+            </a:lvl9pPr>
+          </a:lstStyle>
+          <a:p xmlns:a="http://schemas.openxmlformats.org/drawingml/2006/main">
+            <a:pPr>
+              <a:defRPr sz="1725" b="1">
+                <a:solidFill>
+                  <a:srgbClr val="253F39"/>
+                </a:solidFill>
+                <a:latin typeface="Helvetica Neue"/>
+                <a:ea typeface="Helvetica Neue"/>
+                <a:cs typeface="Helvetica Neue"/>
+              </a:defRPr>
+            </a:pPr>
+            <a:r>
+              <a:rPr sz="1725" b="1">
+                <a:solidFill>
+                  <a:srgbClr val="253F39"/>
+                </a:solidFill>
+                <a:latin typeface="Helvetica Neue"/>
+                <a:ea typeface="Helvetica Neue"/>
+                <a:cs typeface="Helvetica Neue"/>
+              </a:rPr>
+              <a:t>Expected verdicts matched</a:t>
+            </a:r>
+          </a:p>
+        </p:txBody>
+      </p:sp>
+      <p:sp>
+        <p:nvSpPr>
+          <p:cNvPr id="16" name="">
+            <a:extLst xmlns:a="http://schemas.openxmlformats.org/drawingml/2006/main">
+              <a:ext uri="{FF2B5EF4-FFF2-40B4-BE49-F238E27FC236}">
+                <a16:creationId xmlns:a16="http://schemas.microsoft.com/office/drawing/2014/main" id="{895A52FD-D4F3-4257-B5E2-9543FB8A5438}"/>
+              </a:ext>
+            </a:extLst>
+          </p:cNvPr>
+          <p:cNvSpPr>
+            <a:spLocks xmlns:a="http://schemas.openxmlformats.org/drawingml/2006/main" noGrp="1"/>
+          </p:cNvSpPr>
+          <p:nvPr/>
+        </p:nvSpPr>
+        <p:spPr>
+          <a:xfrm xmlns:a="http://schemas.openxmlformats.org/drawingml/2006/main">
+            <a:off x="7239000" y="3343275"/>
+            <a:ext cx="4495800" cy="581025"/>
+          </a:xfrm>
+          <a:prstGeom xmlns:a="http://schemas.openxmlformats.org/drawingml/2006/main" prst="rect">
+            <a:avLst/>
+          </a:prstGeom>
+          <a:noFill xmlns:a="http://schemas.openxmlformats.org/drawingml/2006/main"/>
+          <a:ln xmlns:a="http://schemas.openxmlformats.org/drawingml/2006/main" w="0">
+            <a:noFill/>
+          </a:ln>
+        </p:spPr>
+        <p:txBody>
+          <a:bodyPr xmlns:a="http://schemas.openxmlformats.org/drawingml/2006/main" lIns="0" tIns="0" rIns="0" bIns="0">
+            <a:noAutofit/>
+          </a:bodyPr>
+          <a:lstStyle xmlns:a="http://schemas.openxmlformats.org/drawingml/2006/main">
+            <a:defPPr>
+              <a:defRPr sz="1500" b="0">
+                <a:solidFill>
+                  <a:srgbClr val="253F39"/>
+                </a:solidFill>
+                <a:latin typeface="Helvetica Neue"/>
+                <a:ea typeface="Helvetica Neue"/>
+                <a:cs typeface="Helvetica Neue"/>
+              </a:defRPr>
+            </a:defPPr>
+            <a:lvl1pPr>
+              <a:defRPr sz="1500" b="0">
+                <a:solidFill>
+                  <a:srgbClr val="253F39"/>
+                </a:solidFill>
+                <a:latin typeface="Helvetica Neue"/>
+                <a:ea typeface="Helvetica Neue"/>
+                <a:cs typeface="Helvetica Neue"/>
+              </a:defRPr>
+            </a:lvl1pPr>
+            <a:lvl2pPr>
+              <a:defRPr sz="1500" b="0">
+                <a:solidFill>
+                  <a:srgbClr val="253F39"/>
+                </a:solidFill>
+                <a:latin typeface="Helvetica Neue"/>
+                <a:ea typeface="Helvetica Neue"/>
+                <a:cs typeface="Helvetica Neue"/>
+              </a:defRPr>
+            </a:lvl2pPr>
+            <a:lvl3pPr>
+              <a:defRPr sz="1500" b="0">
+                <a:solidFill>
+                  <a:srgbClr val="253F39"/>
+                </a:solidFill>
+                <a:latin typeface="Helvetica Neue"/>
+                <a:ea typeface="Helvetica Neue"/>
+                <a:cs typeface="Helvetica Neue"/>
+              </a:defRPr>
+            </a:lvl3pPr>
+            <a:lvl4pPr>
+              <a:defRPr sz="1500" b="0">
+                <a:solidFill>
+                  <a:srgbClr val="253F39"/>
+                </a:solidFill>
+                <a:latin typeface="Helvetica Neue"/>
+                <a:ea typeface="Helvetica Neue"/>
+                <a:cs typeface="Helvetica Neue"/>
+              </a:defRPr>
+            </a:lvl4pPr>
+            <a:lvl5pPr>
+              <a:defRPr sz="1500" b="0">
+                <a:solidFill>
+                  <a:srgbClr val="253F39"/>
+                </a:solidFill>
+                <a:latin typeface="Helvetica Neue"/>
+                <a:ea typeface="Helvetica Neue"/>
+                <a:cs typeface="Helvetica Neue"/>
+              </a:defRPr>
+            </a:lvl5pPr>
+            <a:lvl6pPr>
+              <a:defRPr sz="1500" b="0">
+                <a:solidFill>
+                  <a:srgbClr val="253F39"/>
+                </a:solidFill>
+                <a:latin typeface="Helvetica Neue"/>
+                <a:ea typeface="Helvetica Neue"/>
+                <a:cs typeface="Helvetica Neue"/>
+              </a:defRPr>
+            </a:lvl6pPr>
+            <a:lvl7pPr>
+              <a:defRPr sz="1500" b="0">
+                <a:solidFill>
+                  <a:srgbClr val="253F39"/>
+                </a:solidFill>
+                <a:latin typeface="Helvetica Neue"/>
+                <a:ea typeface="Helvetica Neue"/>
+                <a:cs typeface="Helvetica Neue"/>
+              </a:defRPr>
+            </a:lvl7pPr>
+            <a:lvl8pPr>
+              <a:defRPr sz="1500" b="0">
+                <a:solidFill>
+                  <a:srgbClr val="253F39"/>
+                </a:solidFill>
+                <a:latin typeface="Helvetica Neue"/>
+                <a:ea typeface="Helvetica Neue"/>
+                <a:cs typeface="Helvetica Neue"/>
+              </a:defRPr>
+            </a:lvl8pPr>
+            <a:lvl9pPr>
+              <a:defRPr sz="1500" b="0">
+                <a:solidFill>
+                  <a:srgbClr val="253F39"/>
+                </a:solidFill>
+                <a:latin typeface="Helvetica Neue"/>
+                <a:ea typeface="Helvetica Neue"/>
+                <a:cs typeface="Helvetica Neue"/>
+              </a:defRPr>
+            </a:lvl9pPr>
+          </a:lstStyle>
+          <a:p xmlns:a="http://schemas.openxmlformats.org/drawingml/2006/main">
+            <a:pPr>
+              <a:defRPr sz="1500" b="0">
+                <a:solidFill>
+                  <a:srgbClr val="253F39"/>
+                </a:solidFill>
+                <a:latin typeface="Helvetica Neue"/>
+                <a:ea typeface="Helvetica Neue"/>
+                <a:cs typeface="Helvetica Neue"/>
+              </a:defRPr>
+            </a:pPr>
+            <a:r>
+              <a:rPr sz="1500" b="0">
+                <a:solidFill>
+                  <a:srgbClr val="253F39"/>
+                </a:solidFill>
+                <a:latin typeface="Helvetica Neue"/>
+                <a:ea typeface="Helvetica Neue"/>
+                <a:cs typeface="Helvetica Neue"/>
+              </a:rPr>
+              <a:t>12 synthetic cases. Seven human confirmations</a:t>
             </a:r>
           </a:p>
           <a:p xmlns:a="http://schemas.openxmlformats.org/drawingml/2006/main">
             <a:pPr>
-              <a:defRPr sz="2025" b="0">
+              <a:defRPr sz="1500" b="0">
                 <a:solidFill>
                   <a:srgbClr val="253F39"/>
                 </a:solidFill>
@@ -1717,7 +3605,7 @@
               </a:defRPr>
             </a:pPr>
             <a:r>
-              <a:rPr sz="2025" b="0">
+              <a:rPr sz="1500" b="0">
                 <a:solidFill>
                   <a:srgbClr val="253F39"/>
                 </a:solidFill>
@@ -1725,7 +3613,573 @@
                 <a:ea typeface="Helvetica Neue"/>
                 <a:cs typeface="Helvetica Neue"/>
               </a:rPr>
-              <a:t>Compare investigation time and supported decisions.</a:t>
+              <a:t>supplied. No model calls.</a:t>
+            </a:r>
+          </a:p>
+        </p:txBody>
+      </p:sp>
+      <p:sp>
+        <p:nvSpPr>
+          <p:cNvPr id="17" name="">
+            <a:extLst xmlns:a="http://schemas.openxmlformats.org/drawingml/2006/main">
+              <a:ext uri="{FF2B5EF4-FFF2-40B4-BE49-F238E27FC236}">
+                <a16:creationId xmlns:a16="http://schemas.microsoft.com/office/drawing/2014/main" id="{6C318041-469E-4912-A0E9-5C3ACA48F6D5}"/>
+              </a:ext>
+            </a:extLst>
+          </p:cNvPr>
+          <p:cNvSpPr>
+            <a:spLocks xmlns:a="http://schemas.openxmlformats.org/drawingml/2006/main" noGrp="1"/>
+          </p:cNvSpPr>
+          <p:nvPr/>
+        </p:nvSpPr>
+        <p:spPr>
+          <a:xfrm xmlns:a="http://schemas.openxmlformats.org/drawingml/2006/main">
+            <a:off x="7239000" y="4191000"/>
+            <a:ext cx="4495800" cy="285750"/>
+          </a:xfrm>
+          <a:prstGeom xmlns:a="http://schemas.openxmlformats.org/drawingml/2006/main" prst="rect">
+            <a:avLst/>
+          </a:prstGeom>
+          <a:noFill xmlns:a="http://schemas.openxmlformats.org/drawingml/2006/main"/>
+          <a:ln xmlns:a="http://schemas.openxmlformats.org/drawingml/2006/main" w="0">
+            <a:noFill/>
+          </a:ln>
+        </p:spPr>
+        <p:txBody>
+          <a:bodyPr xmlns:a="http://schemas.openxmlformats.org/drawingml/2006/main" lIns="0" tIns="0" rIns="0" bIns="0">
+            <a:noAutofit/>
+          </a:bodyPr>
+          <a:lstStyle xmlns:a="http://schemas.openxmlformats.org/drawingml/2006/main">
+            <a:defPPr>
+              <a:defRPr sz="1575" b="1">
+                <a:solidFill>
+                  <a:srgbClr val="174D46"/>
+                </a:solidFill>
+                <a:latin typeface="Helvetica Neue"/>
+                <a:ea typeface="Helvetica Neue"/>
+                <a:cs typeface="Helvetica Neue"/>
+              </a:defRPr>
+            </a:defPPr>
+            <a:lvl1pPr>
+              <a:defRPr sz="1575" b="1">
+                <a:solidFill>
+                  <a:srgbClr val="174D46"/>
+                </a:solidFill>
+                <a:latin typeface="Helvetica Neue"/>
+                <a:ea typeface="Helvetica Neue"/>
+                <a:cs typeface="Helvetica Neue"/>
+              </a:defRPr>
+            </a:lvl1pPr>
+            <a:lvl2pPr>
+              <a:defRPr sz="1575" b="1">
+                <a:solidFill>
+                  <a:srgbClr val="174D46"/>
+                </a:solidFill>
+                <a:latin typeface="Helvetica Neue"/>
+                <a:ea typeface="Helvetica Neue"/>
+                <a:cs typeface="Helvetica Neue"/>
+              </a:defRPr>
+            </a:lvl2pPr>
+            <a:lvl3pPr>
+              <a:defRPr sz="1575" b="1">
+                <a:solidFill>
+                  <a:srgbClr val="174D46"/>
+                </a:solidFill>
+                <a:latin typeface="Helvetica Neue"/>
+                <a:ea typeface="Helvetica Neue"/>
+                <a:cs typeface="Helvetica Neue"/>
+              </a:defRPr>
+            </a:lvl3pPr>
+            <a:lvl4pPr>
+              <a:defRPr sz="1575" b="1">
+                <a:solidFill>
+                  <a:srgbClr val="174D46"/>
+                </a:solidFill>
+                <a:latin typeface="Helvetica Neue"/>
+                <a:ea typeface="Helvetica Neue"/>
+                <a:cs typeface="Helvetica Neue"/>
+              </a:defRPr>
+            </a:lvl4pPr>
+            <a:lvl5pPr>
+              <a:defRPr sz="1575" b="1">
+                <a:solidFill>
+                  <a:srgbClr val="174D46"/>
+                </a:solidFill>
+                <a:latin typeface="Helvetica Neue"/>
+                <a:ea typeface="Helvetica Neue"/>
+                <a:cs typeface="Helvetica Neue"/>
+              </a:defRPr>
+            </a:lvl5pPr>
+            <a:lvl6pPr>
+              <a:defRPr sz="1575" b="1">
+                <a:solidFill>
+                  <a:srgbClr val="174D46"/>
+                </a:solidFill>
+                <a:latin typeface="Helvetica Neue"/>
+                <a:ea typeface="Helvetica Neue"/>
+                <a:cs typeface="Helvetica Neue"/>
+              </a:defRPr>
+            </a:lvl6pPr>
+            <a:lvl7pPr>
+              <a:defRPr sz="1575" b="1">
+                <a:solidFill>
+                  <a:srgbClr val="174D46"/>
+                </a:solidFill>
+                <a:latin typeface="Helvetica Neue"/>
+                <a:ea typeface="Helvetica Neue"/>
+                <a:cs typeface="Helvetica Neue"/>
+              </a:defRPr>
+            </a:lvl7pPr>
+            <a:lvl8pPr>
+              <a:defRPr sz="1575" b="1">
+                <a:solidFill>
+                  <a:srgbClr val="174D46"/>
+                </a:solidFill>
+                <a:latin typeface="Helvetica Neue"/>
+                <a:ea typeface="Helvetica Neue"/>
+                <a:cs typeface="Helvetica Neue"/>
+              </a:defRPr>
+            </a:lvl8pPr>
+            <a:lvl9pPr>
+              <a:defRPr sz="1575" b="1">
+                <a:solidFill>
+                  <a:srgbClr val="174D46"/>
+                </a:solidFill>
+                <a:latin typeface="Helvetica Neue"/>
+                <a:ea typeface="Helvetica Neue"/>
+                <a:cs typeface="Helvetica Neue"/>
+              </a:defRPr>
+            </a:lvl9pPr>
+          </a:lstStyle>
+          <a:p xmlns:a="http://schemas.openxmlformats.org/drawingml/2006/main">
+            <a:pPr>
+              <a:defRPr sz="1575" b="1">
+                <a:solidFill>
+                  <a:srgbClr val="174D46"/>
+                </a:solidFill>
+                <a:latin typeface="Helvetica Neue"/>
+                <a:ea typeface="Helvetica Neue"/>
+                <a:cs typeface="Helvetica Neue"/>
+              </a:defRPr>
+            </a:pPr>
+            <a:r>
+              <a:rPr sz="1575" b="1">
+                <a:solidFill>
+                  <a:srgbClr val="174D46"/>
+                </a:solidFill>
+                <a:latin typeface="Helvetica Neue"/>
+                <a:ea typeface="Helvetica Neue"/>
+                <a:cs typeface="Helvetica Neue"/>
+              </a:rPr>
+              <a:t>5. Execution &amp; Pitch</a:t>
+            </a:r>
+          </a:p>
+        </p:txBody>
+      </p:sp>
+      <p:sp>
+        <p:nvSpPr>
+          <p:cNvPr id="18" name="">
+            <a:extLst xmlns:a="http://schemas.openxmlformats.org/drawingml/2006/main">
+              <a:ext uri="{FF2B5EF4-FFF2-40B4-BE49-F238E27FC236}">
+                <a16:creationId xmlns:a16="http://schemas.microsoft.com/office/drawing/2014/main" id="{285BFFF5-EE92-4379-A636-225E91F9128C}"/>
+              </a:ext>
+            </a:extLst>
+          </p:cNvPr>
+          <p:cNvSpPr>
+            <a:spLocks xmlns:a="http://schemas.openxmlformats.org/drawingml/2006/main" noGrp="1"/>
+          </p:cNvSpPr>
+          <p:nvPr/>
+        </p:nvSpPr>
+        <p:spPr>
+          <a:xfrm xmlns:a="http://schemas.openxmlformats.org/drawingml/2006/main">
+            <a:off x="7239000" y="4562475"/>
+            <a:ext cx="4495800" cy="1333500"/>
+          </a:xfrm>
+          <a:prstGeom xmlns:a="http://schemas.openxmlformats.org/drawingml/2006/main" prst="rect">
+            <a:avLst/>
+          </a:prstGeom>
+          <a:noFill xmlns:a="http://schemas.openxmlformats.org/drawingml/2006/main"/>
+          <a:ln xmlns:a="http://schemas.openxmlformats.org/drawingml/2006/main" w="0">
+            <a:noFill/>
+          </a:ln>
+        </p:spPr>
+        <p:txBody>
+          <a:bodyPr xmlns:a="http://schemas.openxmlformats.org/drawingml/2006/main" lIns="0" tIns="0" rIns="0" bIns="0">
+            <a:noAutofit/>
+          </a:bodyPr>
+          <a:lstStyle xmlns:a="http://schemas.openxmlformats.org/drawingml/2006/main">
+            <a:defPPr>
+              <a:defRPr sz="1725" b="0">
+                <a:solidFill>
+                  <a:srgbClr val="253F39"/>
+                </a:solidFill>
+                <a:latin typeface="Helvetica Neue"/>
+                <a:ea typeface="Helvetica Neue"/>
+                <a:cs typeface="Helvetica Neue"/>
+              </a:defRPr>
+            </a:defPPr>
+            <a:lvl1pPr>
+              <a:defRPr sz="1725" b="0">
+                <a:solidFill>
+                  <a:srgbClr val="253F39"/>
+                </a:solidFill>
+                <a:latin typeface="Helvetica Neue"/>
+                <a:ea typeface="Helvetica Neue"/>
+                <a:cs typeface="Helvetica Neue"/>
+              </a:defRPr>
+            </a:lvl1pPr>
+            <a:lvl2pPr>
+              <a:defRPr sz="1725" b="0">
+                <a:solidFill>
+                  <a:srgbClr val="253F39"/>
+                </a:solidFill>
+                <a:latin typeface="Helvetica Neue"/>
+                <a:ea typeface="Helvetica Neue"/>
+                <a:cs typeface="Helvetica Neue"/>
+              </a:defRPr>
+            </a:lvl2pPr>
+            <a:lvl3pPr>
+              <a:defRPr sz="1725" b="0">
+                <a:solidFill>
+                  <a:srgbClr val="253F39"/>
+                </a:solidFill>
+                <a:latin typeface="Helvetica Neue"/>
+                <a:ea typeface="Helvetica Neue"/>
+                <a:cs typeface="Helvetica Neue"/>
+              </a:defRPr>
+            </a:lvl3pPr>
+            <a:lvl4pPr>
+              <a:defRPr sz="1725" b="0">
+                <a:solidFill>
+                  <a:srgbClr val="253F39"/>
+                </a:solidFill>
+                <a:latin typeface="Helvetica Neue"/>
+                <a:ea typeface="Helvetica Neue"/>
+                <a:cs typeface="Helvetica Neue"/>
+              </a:defRPr>
+            </a:lvl4pPr>
+            <a:lvl5pPr>
+              <a:defRPr sz="1725" b="0">
+                <a:solidFill>
+                  <a:srgbClr val="253F39"/>
+                </a:solidFill>
+                <a:latin typeface="Helvetica Neue"/>
+                <a:ea typeface="Helvetica Neue"/>
+                <a:cs typeface="Helvetica Neue"/>
+              </a:defRPr>
+            </a:lvl5pPr>
+            <a:lvl6pPr>
+              <a:defRPr sz="1725" b="0">
+                <a:solidFill>
+                  <a:srgbClr val="253F39"/>
+                </a:solidFill>
+                <a:latin typeface="Helvetica Neue"/>
+                <a:ea typeface="Helvetica Neue"/>
+                <a:cs typeface="Helvetica Neue"/>
+              </a:defRPr>
+            </a:lvl6pPr>
+            <a:lvl7pPr>
+              <a:defRPr sz="1725" b="0">
+                <a:solidFill>
+                  <a:srgbClr val="253F39"/>
+                </a:solidFill>
+                <a:latin typeface="Helvetica Neue"/>
+                <a:ea typeface="Helvetica Neue"/>
+                <a:cs typeface="Helvetica Neue"/>
+              </a:defRPr>
+            </a:lvl7pPr>
+            <a:lvl8pPr>
+              <a:defRPr sz="1725" b="0">
+                <a:solidFill>
+                  <a:srgbClr val="253F39"/>
+                </a:solidFill>
+                <a:latin typeface="Helvetica Neue"/>
+                <a:ea typeface="Helvetica Neue"/>
+                <a:cs typeface="Helvetica Neue"/>
+              </a:defRPr>
+            </a:lvl8pPr>
+            <a:lvl9pPr>
+              <a:defRPr sz="1725" b="0">
+                <a:solidFill>
+                  <a:srgbClr val="253F39"/>
+                </a:solidFill>
+                <a:latin typeface="Helvetica Neue"/>
+                <a:ea typeface="Helvetica Neue"/>
+                <a:cs typeface="Helvetica Neue"/>
+              </a:defRPr>
+            </a:lvl9pPr>
+          </a:lstStyle>
+          <a:p xmlns:a="http://schemas.openxmlformats.org/drawingml/2006/main">
+            <a:pPr>
+              <a:defRPr sz="1725" b="0">
+                <a:solidFill>
+                  <a:srgbClr val="253F39"/>
+                </a:solidFill>
+                <a:latin typeface="Helvetica Neue"/>
+                <a:ea typeface="Helvetica Neue"/>
+                <a:cs typeface="Helvetica Neue"/>
+              </a:defRPr>
+            </a:pPr>
+            <a:r>
+              <a:rPr sz="1725" b="0">
+                <a:solidFill>
+                  <a:srgbClr val="253F39"/>
+                </a:solidFill>
+                <a:latin typeface="Helvetica Neue"/>
+                <a:ea typeface="Helvetica Neue"/>
+                <a:cs typeface="Helvetica Neue"/>
+              </a:rPr>
+              <a:t>Why now: public recalls and delivery exports</a:t>
+            </a:r>
+          </a:p>
+          <a:p xmlns:a="http://schemas.openxmlformats.org/drawingml/2006/main">
+            <a:pPr>
+              <a:defRPr sz="1725" b="0">
+                <a:solidFill>
+                  <a:srgbClr val="253F39"/>
+                </a:solidFill>
+                <a:latin typeface="Helvetica Neue"/>
+                <a:ea typeface="Helvetica Neue"/>
+                <a:cs typeface="Helvetica Neue"/>
+              </a:defRPr>
+            </a:pPr>
+            <a:r>
+              <a:rPr sz="1725" b="0">
+                <a:solidFill>
+                  <a:srgbClr val="253F39"/>
+                </a:solidFill>
+                <a:latin typeface="Helvetica Neue"/>
+                <a:ea typeface="Helvetica Neue"/>
+                <a:cs typeface="Helvetica Neue"/>
+              </a:rPr>
+              <a:t>make a focused pilot possible.</a:t>
+            </a:r>
+          </a:p>
+          <a:p xmlns:a="http://schemas.openxmlformats.org/drawingml/2006/main">
+            <a:pPr>
+              <a:defRPr sz="1725" b="0">
+                <a:solidFill>
+                  <a:srgbClr val="253F39"/>
+                </a:solidFill>
+                <a:latin typeface="Helvetica Neue"/>
+                <a:ea typeface="Helvetica Neue"/>
+                <a:cs typeface="Helvetica Neue"/>
+              </a:defRPr>
+            </a:pPr>
+            <a:r>
+              <a:rPr sz="1725" b="0">
+                <a:solidFill>
+                  <a:srgbClr val="253F39"/>
+                </a:solidFill>
+                <a:latin typeface="Helvetica Neue"/>
+                <a:ea typeface="Helvetica Neue"/>
+                <a:cs typeface="Helvetica Neue"/>
+              </a:rPr>
+              <a:t>First users: recruit grocery operators for</a:t>
+            </a:r>
+          </a:p>
+          <a:p xmlns:a="http://schemas.openxmlformats.org/drawingml/2006/main">
+            <a:pPr>
+              <a:defRPr sz="1725" b="0">
+                <a:solidFill>
+                  <a:srgbClr val="253F39"/>
+                </a:solidFill>
+                <a:latin typeface="Helvetica Neue"/>
+                <a:ea typeface="Helvetica Neue"/>
+                <a:cs typeface="Helvetica Neue"/>
+              </a:defRPr>
+            </a:pPr>
+            <a:r>
+              <a:rPr sz="1725" b="0">
+                <a:solidFill>
+                  <a:srgbClr val="253F39"/>
+                </a:solidFill>
+                <a:latin typeface="Helvetica Neue"/>
+                <a:ea typeface="Helvetica Neue"/>
+                <a:cs typeface="Helvetica Neue"/>
+              </a:rPr>
+              <a:t>supervised historical pilots. Measure</a:t>
+            </a:r>
+          </a:p>
+          <a:p xmlns:a="http://schemas.openxmlformats.org/drawingml/2006/main">
+            <a:pPr>
+              <a:defRPr sz="1725" b="0">
+                <a:solidFill>
+                  <a:srgbClr val="253F39"/>
+                </a:solidFill>
+                <a:latin typeface="Helvetica Neue"/>
+                <a:ea typeface="Helvetica Neue"/>
+                <a:cs typeface="Helvetica Neue"/>
+              </a:defRPr>
+            </a:pPr>
+            <a:r>
+              <a:rPr sz="1725" b="0">
+                <a:solidFill>
+                  <a:srgbClr val="253F39"/>
+                </a:solidFill>
+                <a:latin typeface="Helvetica Neue"/>
+                <a:ea typeface="Helvetica Neue"/>
+                <a:cs typeface="Helvetica Neue"/>
+              </a:rPr>
+              <a:t>investigation time and supported decisions.</a:t>
+            </a:r>
+          </a:p>
+        </p:txBody>
+      </p:sp>
+      <p:sp>
+        <p:nvSpPr>
+          <p:cNvPr id="19" name="">
+            <a:extLst xmlns:a="http://schemas.openxmlformats.org/drawingml/2006/main">
+              <a:ext uri="{FF2B5EF4-FFF2-40B4-BE49-F238E27FC236}">
+                <a16:creationId xmlns:a16="http://schemas.microsoft.com/office/drawing/2014/main" id="{FB49BEEC-107F-4188-B4C5-3E970FDD65EC}"/>
+              </a:ext>
+            </a:extLst>
+          </p:cNvPr>
+          <p:cNvSpPr>
+            <a:spLocks xmlns:a="http://schemas.openxmlformats.org/drawingml/2006/main" noGrp="1"/>
+          </p:cNvSpPr>
+          <p:nvPr/>
+        </p:nvSpPr>
+        <p:spPr>
+          <a:xfrm xmlns:a="http://schemas.openxmlformats.org/drawingml/2006/main">
+            <a:off x="457200" y="6267450"/>
+            <a:ext cx="11277600" cy="342900"/>
+          </a:xfrm>
+          <a:prstGeom xmlns:a="http://schemas.openxmlformats.org/drawingml/2006/main" prst="rect">
+            <a:avLst/>
+          </a:prstGeom>
+          <a:noFill xmlns:a="http://schemas.openxmlformats.org/drawingml/2006/main"/>
+          <a:ln xmlns:a="http://schemas.openxmlformats.org/drawingml/2006/main" w="0">
+            <a:noFill/>
+          </a:ln>
+        </p:spPr>
+        <p:txBody>
+          <a:bodyPr xmlns:a="http://schemas.openxmlformats.org/drawingml/2006/main" lIns="0" tIns="0" rIns="0" bIns="0">
+            <a:noAutofit/>
+          </a:bodyPr>
+          <a:lstStyle xmlns:a="http://schemas.openxmlformats.org/drawingml/2006/main">
+            <a:defPPr>
+              <a:defRPr sz="1500" b="0">
+                <a:solidFill>
+                  <a:srgbClr val="345D54"/>
+                </a:solidFill>
+                <a:latin typeface="Helvetica Neue"/>
+                <a:ea typeface="Helvetica Neue"/>
+                <a:cs typeface="Helvetica Neue"/>
+              </a:defRPr>
+            </a:defPPr>
+            <a:lvl1pPr>
+              <a:defRPr sz="1500" b="0">
+                <a:solidFill>
+                  <a:srgbClr val="345D54"/>
+                </a:solidFill>
+                <a:latin typeface="Helvetica Neue"/>
+                <a:ea typeface="Helvetica Neue"/>
+                <a:cs typeface="Helvetica Neue"/>
+              </a:defRPr>
+            </a:lvl1pPr>
+            <a:lvl2pPr>
+              <a:defRPr sz="1500" b="0">
+                <a:solidFill>
+                  <a:srgbClr val="345D54"/>
+                </a:solidFill>
+                <a:latin typeface="Helvetica Neue"/>
+                <a:ea typeface="Helvetica Neue"/>
+                <a:cs typeface="Helvetica Neue"/>
+              </a:defRPr>
+            </a:lvl2pPr>
+            <a:lvl3pPr>
+              <a:defRPr sz="1500" b="0">
+                <a:solidFill>
+                  <a:srgbClr val="345D54"/>
+                </a:solidFill>
+                <a:latin typeface="Helvetica Neue"/>
+                <a:ea typeface="Helvetica Neue"/>
+                <a:cs typeface="Helvetica Neue"/>
+              </a:defRPr>
+            </a:lvl3pPr>
+            <a:lvl4pPr>
+              <a:defRPr sz="1500" b="0">
+                <a:solidFill>
+                  <a:srgbClr val="345D54"/>
+                </a:solidFill>
+                <a:latin typeface="Helvetica Neue"/>
+                <a:ea typeface="Helvetica Neue"/>
+                <a:cs typeface="Helvetica Neue"/>
+              </a:defRPr>
+            </a:lvl4pPr>
+            <a:lvl5pPr>
+              <a:defRPr sz="1500" b="0">
+                <a:solidFill>
+                  <a:srgbClr val="345D54"/>
+                </a:solidFill>
+                <a:latin typeface="Helvetica Neue"/>
+                <a:ea typeface="Helvetica Neue"/>
+                <a:cs typeface="Helvetica Neue"/>
+              </a:defRPr>
+            </a:lvl5pPr>
+            <a:lvl6pPr>
+              <a:defRPr sz="1500" b="0">
+                <a:solidFill>
+                  <a:srgbClr val="345D54"/>
+                </a:solidFill>
+                <a:latin typeface="Helvetica Neue"/>
+                <a:ea typeface="Helvetica Neue"/>
+                <a:cs typeface="Helvetica Neue"/>
+              </a:defRPr>
+            </a:lvl6pPr>
+            <a:lvl7pPr>
+              <a:defRPr sz="1500" b="0">
+                <a:solidFill>
+                  <a:srgbClr val="345D54"/>
+                </a:solidFill>
+                <a:latin typeface="Helvetica Neue"/>
+                <a:ea typeface="Helvetica Neue"/>
+                <a:cs typeface="Helvetica Neue"/>
+              </a:defRPr>
+            </a:lvl7pPr>
+            <a:lvl8pPr>
+              <a:defRPr sz="1500" b="0">
+                <a:solidFill>
+                  <a:srgbClr val="345D54"/>
+                </a:solidFill>
+                <a:latin typeface="Helvetica Neue"/>
+                <a:ea typeface="Helvetica Neue"/>
+                <a:cs typeface="Helvetica Neue"/>
+              </a:defRPr>
+            </a:lvl8pPr>
+            <a:lvl9pPr>
+              <a:defRPr sz="1500" b="0">
+                <a:solidFill>
+                  <a:srgbClr val="345D54"/>
+                </a:solidFill>
+                <a:latin typeface="Helvetica Neue"/>
+                <a:ea typeface="Helvetica Neue"/>
+                <a:cs typeface="Helvetica Neue"/>
+              </a:defRPr>
+            </a:lvl9pPr>
+          </a:lstStyle>
+          <a:p xmlns:a="http://schemas.openxmlformats.org/drawingml/2006/main">
+            <a:pPr>
+              <a:defRPr sz="1500" b="0">
+                <a:solidFill>
+                  <a:srgbClr val="345D54"/>
+                </a:solidFill>
+                <a:latin typeface="Helvetica Neue"/>
+                <a:ea typeface="Helvetica Neue"/>
+                <a:cs typeface="Helvetica Neue"/>
+              </a:defRPr>
+            </a:pPr>
+            <a:r>
+              <a:rPr sz="1500" b="0">
+                <a:solidFill>
+                  <a:srgbClr val="345D54"/>
+                </a:solidFill>
+                <a:latin typeface="Helvetica Neue"/>
+                <a:ea typeface="Helvetica Neue"/>
+                <a:cs typeface="Helvetica Neue"/>
+              </a:rPr>
+              <a:t>Historical recall with fictional business records. Working local demo. Aiven deployment pending.</a:t>
             </a:r>
           </a:p>
         </p:txBody>

</xml_diff>

<commit_message>
docs: make first-user outreach explicit on submission slide
</commit_message>
<xml_diff>
--- a/docs/recallops-pitch.pptx
+++ b/docs/recallops-pitch.pptx
@@ -2,13 +2,13 @@
 <file path=ppt/presentation.xml><?xml version="1.0" encoding="utf-8"?>
 <p:presentation xmlns:p="http://schemas.openxmlformats.org/presentationml/2006/main">
   <p:sldMasterIdLst>
-    <p:sldMasterId xmlns:r="http://schemas.openxmlformats.org/officeDocument/2006/relationships" id="2147483648" r:id="Ra98006ccf63d4c86"/>
+    <p:sldMasterId xmlns:r="http://schemas.openxmlformats.org/officeDocument/2006/relationships" id="2147483648" r:id="R1d8c724b17504be3"/>
   </p:sldMasterIdLst>
   <p:notesMasterIdLst>
-    <p:notesMasterId xmlns:r="http://schemas.openxmlformats.org/officeDocument/2006/relationships" r:id="R0e9e8348e5644972"/>
+    <p:notesMasterId xmlns:r="http://schemas.openxmlformats.org/officeDocument/2006/relationships" r:id="R73fa51bebcdd450b"/>
   </p:notesMasterIdLst>
   <p:sldIdLst>
-    <p:sldId xmlns:r="http://schemas.openxmlformats.org/officeDocument/2006/relationships" id="256" r:id="R2f376dcb157a4d78"/>
+    <p:sldId xmlns:r="http://schemas.openxmlformats.org/officeDocument/2006/relationships" id="256" r:id="R42188b5e9ce74f27"/>
   </p:sldIdLst>
   <p:sldSz cx="12192000" cy="6858000"/>
   <p:notesSz cx="6858000" cy="9144000"/>
@@ -550,7 +550,7 @@
   </p:cSld>
   <p:clrMap bg1="lt1" tx1="dk1" bg2="lt2" tx2="dk2" accent1="accent1" accent2="accent2" accent3="accent3" accent4="accent4" accent5="accent5" accent6="accent6" hlink="hlink" folHlink="folHlink"/>
   <p:sldLayoutIdLst>
-    <p:sldLayoutId xmlns:r="http://schemas.openxmlformats.org/officeDocument/2006/relationships" id="2147483649" r:id="Rb7e4c7d4d6434590"/>
+    <p:sldLayoutId xmlns:r="http://schemas.openxmlformats.org/officeDocument/2006/relationships" id="2147483649" r:id="R55abd43bf102485f"/>
   </p:sldLayoutIdLst>
   <p:txStyles>
     <p:titleStyle>
@@ -1139,6 +1139,7 @@
               </a:defRPr>
             </a:defPPr>
             <a:lvl1pPr>
+              <a:buNone/>
               <a:defRPr sz="3900" b="1">
                 <a:solidFill>
                   <a:srgbClr val="174D46"/>
@@ -1149,6 +1150,7 @@
               </a:defRPr>
             </a:lvl1pPr>
             <a:lvl2pPr>
+              <a:buNone/>
               <a:defRPr sz="3900" b="1">
                 <a:solidFill>
                   <a:srgbClr val="174D46"/>
@@ -1159,6 +1161,7 @@
               </a:defRPr>
             </a:lvl2pPr>
             <a:lvl3pPr>
+              <a:buNone/>
               <a:defRPr sz="3900" b="1">
                 <a:solidFill>
                   <a:srgbClr val="174D46"/>
@@ -1169,6 +1172,7 @@
               </a:defRPr>
             </a:lvl3pPr>
             <a:lvl4pPr>
+              <a:buNone/>
               <a:defRPr sz="3900" b="1">
                 <a:solidFill>
                   <a:srgbClr val="174D46"/>
@@ -1179,6 +1183,7 @@
               </a:defRPr>
             </a:lvl4pPr>
             <a:lvl5pPr>
+              <a:buNone/>
               <a:defRPr sz="3900" b="1">
                 <a:solidFill>
                   <a:srgbClr val="174D46"/>
@@ -1189,6 +1194,7 @@
               </a:defRPr>
             </a:lvl5pPr>
             <a:lvl6pPr>
+              <a:buNone/>
               <a:defRPr sz="3900" b="1">
                 <a:solidFill>
                   <a:srgbClr val="174D46"/>
@@ -1199,6 +1205,7 @@
               </a:defRPr>
             </a:lvl6pPr>
             <a:lvl7pPr>
+              <a:buNone/>
               <a:defRPr sz="3900" b="1">
                 <a:solidFill>
                   <a:srgbClr val="174D46"/>
@@ -1209,6 +1216,7 @@
               </a:defRPr>
             </a:lvl7pPr>
             <a:lvl8pPr>
+              <a:buNone/>
               <a:defRPr sz="3900" b="1">
                 <a:solidFill>
                   <a:srgbClr val="174D46"/>
@@ -1219,6 +1227,7 @@
               </a:defRPr>
             </a:lvl8pPr>
             <a:lvl9pPr>
+              <a:buNone/>
               <a:defRPr sz="3900" b="1">
                 <a:solidFill>
                   <a:srgbClr val="174D46"/>
@@ -1298,6 +1307,7 @@
               </a:defRPr>
             </a:defPPr>
             <a:lvl1pPr>
+              <a:buNone/>
               <a:defRPr sz="2025" b="0">
                 <a:solidFill>
                   <a:srgbClr val="345D54"/>
@@ -1308,6 +1318,7 @@
               </a:defRPr>
             </a:lvl1pPr>
             <a:lvl2pPr>
+              <a:buNone/>
               <a:defRPr sz="2025" b="0">
                 <a:solidFill>
                   <a:srgbClr val="345D54"/>
@@ -1318,6 +1329,7 @@
               </a:defRPr>
             </a:lvl2pPr>
             <a:lvl3pPr>
+              <a:buNone/>
               <a:defRPr sz="2025" b="0">
                 <a:solidFill>
                   <a:srgbClr val="345D54"/>
@@ -1328,6 +1340,7 @@
               </a:defRPr>
             </a:lvl3pPr>
             <a:lvl4pPr>
+              <a:buNone/>
               <a:defRPr sz="2025" b="0">
                 <a:solidFill>
                   <a:srgbClr val="345D54"/>
@@ -1338,6 +1351,7 @@
               </a:defRPr>
             </a:lvl4pPr>
             <a:lvl5pPr>
+              <a:buNone/>
               <a:defRPr sz="2025" b="0">
                 <a:solidFill>
                   <a:srgbClr val="345D54"/>
@@ -1348,6 +1362,7 @@
               </a:defRPr>
             </a:lvl5pPr>
             <a:lvl6pPr>
+              <a:buNone/>
               <a:defRPr sz="2025" b="0">
                 <a:solidFill>
                   <a:srgbClr val="345D54"/>
@@ -1358,6 +1373,7 @@
               </a:defRPr>
             </a:lvl6pPr>
             <a:lvl7pPr>
+              <a:buNone/>
               <a:defRPr sz="2025" b="0">
                 <a:solidFill>
                   <a:srgbClr val="345D54"/>
@@ -1368,6 +1384,7 @@
               </a:defRPr>
             </a:lvl7pPr>
             <a:lvl8pPr>
+              <a:buNone/>
               <a:defRPr sz="2025" b="0">
                 <a:solidFill>
                   <a:srgbClr val="345D54"/>
@@ -1378,6 +1395,7 @@
               </a:defRPr>
             </a:lvl8pPr>
             <a:lvl9pPr>
+              <a:buNone/>
               <a:defRPr sz="2025" b="0">
                 <a:solidFill>
                   <a:srgbClr val="345D54"/>
@@ -1457,6 +1475,7 @@
               </a:defRPr>
             </a:defPPr>
             <a:lvl1pPr>
+              <a:buNone/>
               <a:defRPr sz="1575" b="1">
                 <a:solidFill>
                   <a:srgbClr val="174D46"/>
@@ -1467,6 +1486,7 @@
               </a:defRPr>
             </a:lvl1pPr>
             <a:lvl2pPr>
+              <a:buNone/>
               <a:defRPr sz="1575" b="1">
                 <a:solidFill>
                   <a:srgbClr val="174D46"/>
@@ -1477,6 +1497,7 @@
               </a:defRPr>
             </a:lvl2pPr>
             <a:lvl3pPr>
+              <a:buNone/>
               <a:defRPr sz="1575" b="1">
                 <a:solidFill>
                   <a:srgbClr val="174D46"/>
@@ -1487,6 +1508,7 @@
               </a:defRPr>
             </a:lvl3pPr>
             <a:lvl4pPr>
+              <a:buNone/>
               <a:defRPr sz="1575" b="1">
                 <a:solidFill>
                   <a:srgbClr val="174D46"/>
@@ -1497,6 +1519,7 @@
               </a:defRPr>
             </a:lvl4pPr>
             <a:lvl5pPr>
+              <a:buNone/>
               <a:defRPr sz="1575" b="1">
                 <a:solidFill>
                   <a:srgbClr val="174D46"/>
@@ -1507,6 +1530,7 @@
               </a:defRPr>
             </a:lvl5pPr>
             <a:lvl6pPr>
+              <a:buNone/>
               <a:defRPr sz="1575" b="1">
                 <a:solidFill>
                   <a:srgbClr val="174D46"/>
@@ -1517,6 +1541,7 @@
               </a:defRPr>
             </a:lvl6pPr>
             <a:lvl7pPr>
+              <a:buNone/>
               <a:defRPr sz="1575" b="1">
                 <a:solidFill>
                   <a:srgbClr val="174D46"/>
@@ -1527,6 +1552,7 @@
               </a:defRPr>
             </a:lvl7pPr>
             <a:lvl8pPr>
+              <a:buNone/>
               <a:defRPr sz="1575" b="1">
                 <a:solidFill>
                   <a:srgbClr val="174D46"/>
@@ -1537,6 +1563,7 @@
               </a:defRPr>
             </a:lvl8pPr>
             <a:lvl9pPr>
+              <a:buNone/>
               <a:defRPr sz="1575" b="1">
                 <a:solidFill>
                   <a:srgbClr val="174D46"/>
@@ -1616,6 +1643,7 @@
               </a:defRPr>
             </a:defPPr>
             <a:lvl1pPr>
+              <a:buNone/>
               <a:defRPr sz="1800" b="0">
                 <a:solidFill>
                   <a:srgbClr val="253F39"/>
@@ -1626,6 +1654,7 @@
               </a:defRPr>
             </a:lvl1pPr>
             <a:lvl2pPr>
+              <a:buNone/>
               <a:defRPr sz="1800" b="0">
                 <a:solidFill>
                   <a:srgbClr val="253F39"/>
@@ -1636,6 +1665,7 @@
               </a:defRPr>
             </a:lvl2pPr>
             <a:lvl3pPr>
+              <a:buNone/>
               <a:defRPr sz="1800" b="0">
                 <a:solidFill>
                   <a:srgbClr val="253F39"/>
@@ -1646,6 +1676,7 @@
               </a:defRPr>
             </a:lvl3pPr>
             <a:lvl4pPr>
+              <a:buNone/>
               <a:defRPr sz="1800" b="0">
                 <a:solidFill>
                   <a:srgbClr val="253F39"/>
@@ -1656,6 +1687,7 @@
               </a:defRPr>
             </a:lvl4pPr>
             <a:lvl5pPr>
+              <a:buNone/>
               <a:defRPr sz="1800" b="0">
                 <a:solidFill>
                   <a:srgbClr val="253F39"/>
@@ -1666,6 +1698,7 @@
               </a:defRPr>
             </a:lvl5pPr>
             <a:lvl6pPr>
+              <a:buNone/>
               <a:defRPr sz="1800" b="0">
                 <a:solidFill>
                   <a:srgbClr val="253F39"/>
@@ -1676,6 +1709,7 @@
               </a:defRPr>
             </a:lvl6pPr>
             <a:lvl7pPr>
+              <a:buNone/>
               <a:defRPr sz="1800" b="0">
                 <a:solidFill>
                   <a:srgbClr val="253F39"/>
@@ -1686,6 +1720,7 @@
               </a:defRPr>
             </a:lvl7pPr>
             <a:lvl8pPr>
+              <a:buNone/>
               <a:defRPr sz="1800" b="0">
                 <a:solidFill>
                   <a:srgbClr val="253F39"/>
@@ -1696,6 +1731,7 @@
               </a:defRPr>
             </a:lvl8pPr>
             <a:lvl9pPr>
+              <a:buNone/>
               <a:defRPr sz="1800" b="0">
                 <a:solidFill>
                   <a:srgbClr val="253F39"/>
@@ -1799,6 +1835,7 @@
               </a:defRPr>
             </a:defPPr>
             <a:lvl1pPr>
+              <a:buNone/>
               <a:defRPr sz="1575" b="1">
                 <a:solidFill>
                   <a:srgbClr val="174D46"/>
@@ -1809,6 +1846,7 @@
               </a:defRPr>
             </a:lvl1pPr>
             <a:lvl2pPr>
+              <a:buNone/>
               <a:defRPr sz="1575" b="1">
                 <a:solidFill>
                   <a:srgbClr val="174D46"/>
@@ -1819,6 +1857,7 @@
               </a:defRPr>
             </a:lvl2pPr>
             <a:lvl3pPr>
+              <a:buNone/>
               <a:defRPr sz="1575" b="1">
                 <a:solidFill>
                   <a:srgbClr val="174D46"/>
@@ -1829,6 +1868,7 @@
               </a:defRPr>
             </a:lvl3pPr>
             <a:lvl4pPr>
+              <a:buNone/>
               <a:defRPr sz="1575" b="1">
                 <a:solidFill>
                   <a:srgbClr val="174D46"/>
@@ -1839,6 +1879,7 @@
               </a:defRPr>
             </a:lvl4pPr>
             <a:lvl5pPr>
+              <a:buNone/>
               <a:defRPr sz="1575" b="1">
                 <a:solidFill>
                   <a:srgbClr val="174D46"/>
@@ -1849,6 +1890,7 @@
               </a:defRPr>
             </a:lvl5pPr>
             <a:lvl6pPr>
+              <a:buNone/>
               <a:defRPr sz="1575" b="1">
                 <a:solidFill>
                   <a:srgbClr val="174D46"/>
@@ -1859,6 +1901,7 @@
               </a:defRPr>
             </a:lvl6pPr>
             <a:lvl7pPr>
+              <a:buNone/>
               <a:defRPr sz="1575" b="1">
                 <a:solidFill>
                   <a:srgbClr val="174D46"/>
@@ -1869,6 +1912,7 @@
               </a:defRPr>
             </a:lvl7pPr>
             <a:lvl8pPr>
+              <a:buNone/>
               <a:defRPr sz="1575" b="1">
                 <a:solidFill>
                   <a:srgbClr val="174D46"/>
@@ -1879,6 +1923,7 @@
               </a:defRPr>
             </a:lvl8pPr>
             <a:lvl9pPr>
+              <a:buNone/>
               <a:defRPr sz="1575" b="1">
                 <a:solidFill>
                   <a:srgbClr val="174D46"/>
@@ -1958,6 +2003,7 @@
               </a:defRPr>
             </a:defPPr>
             <a:lvl1pPr>
+              <a:buNone/>
               <a:defRPr sz="1800" b="0">
                 <a:solidFill>
                   <a:srgbClr val="253F39"/>
@@ -1968,6 +2014,7 @@
               </a:defRPr>
             </a:lvl1pPr>
             <a:lvl2pPr>
+              <a:buNone/>
               <a:defRPr sz="1800" b="0">
                 <a:solidFill>
                   <a:srgbClr val="253F39"/>
@@ -1978,6 +2025,7 @@
               </a:defRPr>
             </a:lvl2pPr>
             <a:lvl3pPr>
+              <a:buNone/>
               <a:defRPr sz="1800" b="0">
                 <a:solidFill>
                   <a:srgbClr val="253F39"/>
@@ -1988,6 +2036,7 @@
               </a:defRPr>
             </a:lvl3pPr>
             <a:lvl4pPr>
+              <a:buNone/>
               <a:defRPr sz="1800" b="0">
                 <a:solidFill>
                   <a:srgbClr val="253F39"/>
@@ -1998,6 +2047,7 @@
               </a:defRPr>
             </a:lvl4pPr>
             <a:lvl5pPr>
+              <a:buNone/>
               <a:defRPr sz="1800" b="0">
                 <a:solidFill>
                   <a:srgbClr val="253F39"/>
@@ -2008,6 +2058,7 @@
               </a:defRPr>
             </a:lvl5pPr>
             <a:lvl6pPr>
+              <a:buNone/>
               <a:defRPr sz="1800" b="0">
                 <a:solidFill>
                   <a:srgbClr val="253F39"/>
@@ -2018,6 +2069,7 @@
               </a:defRPr>
             </a:lvl6pPr>
             <a:lvl7pPr>
+              <a:buNone/>
               <a:defRPr sz="1800" b="0">
                 <a:solidFill>
                   <a:srgbClr val="253F39"/>
@@ -2028,6 +2080,7 @@
               </a:defRPr>
             </a:lvl7pPr>
             <a:lvl8pPr>
+              <a:buNone/>
               <a:defRPr sz="1800" b="0">
                 <a:solidFill>
                   <a:srgbClr val="253F39"/>
@@ -2038,6 +2091,7 @@
               </a:defRPr>
             </a:lvl8pPr>
             <a:lvl9pPr>
+              <a:buNone/>
               <a:defRPr sz="1800" b="0">
                 <a:solidFill>
                   <a:srgbClr val="253F39"/>
@@ -2165,6 +2219,7 @@
               </a:defRPr>
             </a:defPPr>
             <a:lvl1pPr>
+              <a:buNone/>
               <a:defRPr sz="1575" b="1">
                 <a:solidFill>
                   <a:srgbClr val="174D46"/>
@@ -2175,6 +2230,7 @@
               </a:defRPr>
             </a:lvl1pPr>
             <a:lvl2pPr>
+              <a:buNone/>
               <a:defRPr sz="1575" b="1">
                 <a:solidFill>
                   <a:srgbClr val="174D46"/>
@@ -2185,6 +2241,7 @@
               </a:defRPr>
             </a:lvl2pPr>
             <a:lvl3pPr>
+              <a:buNone/>
               <a:defRPr sz="1575" b="1">
                 <a:solidFill>
                   <a:srgbClr val="174D46"/>
@@ -2195,6 +2252,7 @@
               </a:defRPr>
             </a:lvl3pPr>
             <a:lvl4pPr>
+              <a:buNone/>
               <a:defRPr sz="1575" b="1">
                 <a:solidFill>
                   <a:srgbClr val="174D46"/>
@@ -2205,6 +2263,7 @@
               </a:defRPr>
             </a:lvl4pPr>
             <a:lvl5pPr>
+              <a:buNone/>
               <a:defRPr sz="1575" b="1">
                 <a:solidFill>
                   <a:srgbClr val="174D46"/>
@@ -2215,6 +2274,7 @@
               </a:defRPr>
             </a:lvl5pPr>
             <a:lvl6pPr>
+              <a:buNone/>
               <a:defRPr sz="1575" b="1">
                 <a:solidFill>
                   <a:srgbClr val="174D46"/>
@@ -2225,6 +2285,7 @@
               </a:defRPr>
             </a:lvl6pPr>
             <a:lvl7pPr>
+              <a:buNone/>
               <a:defRPr sz="1575" b="1">
                 <a:solidFill>
                   <a:srgbClr val="174D46"/>
@@ -2235,6 +2296,7 @@
               </a:defRPr>
             </a:lvl7pPr>
             <a:lvl8pPr>
+              <a:buNone/>
               <a:defRPr sz="1575" b="1">
                 <a:solidFill>
                   <a:srgbClr val="174D46"/>
@@ -2245,6 +2307,7 @@
               </a:defRPr>
             </a:lvl8pPr>
             <a:lvl9pPr>
+              <a:buNone/>
               <a:defRPr sz="1575" b="1">
                 <a:solidFill>
                   <a:srgbClr val="174D46"/>
@@ -2324,6 +2387,7 @@
               </a:defRPr>
             </a:defPPr>
             <a:lvl1pPr>
+              <a:buNone/>
               <a:defRPr sz="1800" b="0">
                 <a:solidFill>
                   <a:srgbClr val="253F39"/>
@@ -2334,6 +2398,7 @@
               </a:defRPr>
             </a:lvl1pPr>
             <a:lvl2pPr>
+              <a:buNone/>
               <a:defRPr sz="1800" b="0">
                 <a:solidFill>
                   <a:srgbClr val="253F39"/>
@@ -2344,6 +2409,7 @@
               </a:defRPr>
             </a:lvl2pPr>
             <a:lvl3pPr>
+              <a:buNone/>
               <a:defRPr sz="1800" b="0">
                 <a:solidFill>
                   <a:srgbClr val="253F39"/>
@@ -2354,6 +2420,7 @@
               </a:defRPr>
             </a:lvl3pPr>
             <a:lvl4pPr>
+              <a:buNone/>
               <a:defRPr sz="1800" b="0">
                 <a:solidFill>
                   <a:srgbClr val="253F39"/>
@@ -2364,6 +2431,7 @@
               </a:defRPr>
             </a:lvl4pPr>
             <a:lvl5pPr>
+              <a:buNone/>
               <a:defRPr sz="1800" b="0">
                 <a:solidFill>
                   <a:srgbClr val="253F39"/>
@@ -2374,6 +2442,7 @@
               </a:defRPr>
             </a:lvl5pPr>
             <a:lvl6pPr>
+              <a:buNone/>
               <a:defRPr sz="1800" b="0">
                 <a:solidFill>
                   <a:srgbClr val="253F39"/>
@@ -2384,6 +2453,7 @@
               </a:defRPr>
             </a:lvl6pPr>
             <a:lvl7pPr>
+              <a:buNone/>
               <a:defRPr sz="1800" b="0">
                 <a:solidFill>
                   <a:srgbClr val="253F39"/>
@@ -2394,6 +2464,7 @@
               </a:defRPr>
             </a:lvl7pPr>
             <a:lvl8pPr>
+              <a:buNone/>
               <a:defRPr sz="1800" b="0">
                 <a:solidFill>
                   <a:srgbClr val="253F39"/>
@@ -2404,6 +2475,7 @@
               </a:defRPr>
             </a:lvl8pPr>
             <a:lvl9pPr>
+              <a:buNone/>
               <a:defRPr sz="1800" b="0">
                 <a:solidFill>
                   <a:srgbClr val="253F39"/>
@@ -2531,6 +2603,7 @@
               </a:defRPr>
             </a:defPPr>
             <a:lvl1pPr>
+              <a:buNone/>
               <a:defRPr sz="1575" b="1">
                 <a:solidFill>
                   <a:srgbClr val="174D46"/>
@@ -2541,6 +2614,7 @@
               </a:defRPr>
             </a:lvl1pPr>
             <a:lvl2pPr>
+              <a:buNone/>
               <a:defRPr sz="1575" b="1">
                 <a:solidFill>
                   <a:srgbClr val="174D46"/>
@@ -2551,6 +2625,7 @@
               </a:defRPr>
             </a:lvl2pPr>
             <a:lvl3pPr>
+              <a:buNone/>
               <a:defRPr sz="1575" b="1">
                 <a:solidFill>
                   <a:srgbClr val="174D46"/>
@@ -2561,6 +2636,7 @@
               </a:defRPr>
             </a:lvl3pPr>
             <a:lvl4pPr>
+              <a:buNone/>
               <a:defRPr sz="1575" b="1">
                 <a:solidFill>
                   <a:srgbClr val="174D46"/>
@@ -2571,6 +2647,7 @@
               </a:defRPr>
             </a:lvl4pPr>
             <a:lvl5pPr>
+              <a:buNone/>
               <a:defRPr sz="1575" b="1">
                 <a:solidFill>
                   <a:srgbClr val="174D46"/>
@@ -2581,6 +2658,7 @@
               </a:defRPr>
             </a:lvl5pPr>
             <a:lvl6pPr>
+              <a:buNone/>
               <a:defRPr sz="1575" b="1">
                 <a:solidFill>
                   <a:srgbClr val="174D46"/>
@@ -2591,6 +2669,7 @@
               </a:defRPr>
             </a:lvl6pPr>
             <a:lvl7pPr>
+              <a:buNone/>
               <a:defRPr sz="1575" b="1">
                 <a:solidFill>
                   <a:srgbClr val="174D46"/>
@@ -2601,6 +2680,7 @@
               </a:defRPr>
             </a:lvl7pPr>
             <a:lvl8pPr>
+              <a:buNone/>
               <a:defRPr sz="1575" b="1">
                 <a:solidFill>
                   <a:srgbClr val="174D46"/>
@@ -2611,6 +2691,7 @@
               </a:defRPr>
             </a:lvl8pPr>
             <a:lvl9pPr>
+              <a:buNone/>
               <a:defRPr sz="1575" b="1">
                 <a:solidFill>
                   <a:srgbClr val="174D46"/>
@@ -2690,6 +2771,7 @@
               </a:defRPr>
             </a:defPPr>
             <a:lvl1pPr>
+              <a:buNone/>
               <a:defRPr sz="3675" b="1">
                 <a:solidFill>
                   <a:srgbClr val="527066"/>
@@ -2700,6 +2782,7 @@
               </a:defRPr>
             </a:lvl1pPr>
             <a:lvl2pPr>
+              <a:buNone/>
               <a:defRPr sz="3675" b="1">
                 <a:solidFill>
                   <a:srgbClr val="527066"/>
@@ -2710,6 +2793,7 @@
               </a:defRPr>
             </a:lvl2pPr>
             <a:lvl3pPr>
+              <a:buNone/>
               <a:defRPr sz="3675" b="1">
                 <a:solidFill>
                   <a:srgbClr val="527066"/>
@@ -2720,6 +2804,7 @@
               </a:defRPr>
             </a:lvl3pPr>
             <a:lvl4pPr>
+              <a:buNone/>
               <a:defRPr sz="3675" b="1">
                 <a:solidFill>
                   <a:srgbClr val="527066"/>
@@ -2730,6 +2815,7 @@
               </a:defRPr>
             </a:lvl4pPr>
             <a:lvl5pPr>
+              <a:buNone/>
               <a:defRPr sz="3675" b="1">
                 <a:solidFill>
                   <a:srgbClr val="527066"/>
@@ -2740,6 +2826,7 @@
               </a:defRPr>
             </a:lvl5pPr>
             <a:lvl6pPr>
+              <a:buNone/>
               <a:defRPr sz="3675" b="1">
                 <a:solidFill>
                   <a:srgbClr val="527066"/>
@@ -2750,6 +2837,7 @@
               </a:defRPr>
             </a:lvl6pPr>
             <a:lvl7pPr>
+              <a:buNone/>
               <a:defRPr sz="3675" b="1">
                 <a:solidFill>
                   <a:srgbClr val="527066"/>
@@ -2760,6 +2848,7 @@
               </a:defRPr>
             </a:lvl7pPr>
             <a:lvl8pPr>
+              <a:buNone/>
               <a:defRPr sz="3675" b="1">
                 <a:solidFill>
                   <a:srgbClr val="527066"/>
@@ -2770,6 +2859,7 @@
               </a:defRPr>
             </a:lvl8pPr>
             <a:lvl9pPr>
+              <a:buNone/>
               <a:defRPr sz="3675" b="1">
                 <a:solidFill>
                   <a:srgbClr val="527066"/>
@@ -2782,6 +2872,7 @@
           </a:lstStyle>
           <a:p xmlns:a="http://schemas.openxmlformats.org/drawingml/2006/main">
             <a:pPr>
+              <a:buNone/>
               <a:defRPr sz="3675" b="1">
                 <a:solidFill>
                   <a:srgbClr val="527066"/>
@@ -2848,6 +2939,7 @@
               </a:defRPr>
             </a:defPPr>
             <a:lvl1pPr>
+              <a:buNone/>
               <a:defRPr sz="3675" b="1">
                 <a:solidFill>
                   <a:srgbClr val="174D46"/>
@@ -2858,6 +2950,7 @@
               </a:defRPr>
             </a:lvl1pPr>
             <a:lvl2pPr>
+              <a:buNone/>
               <a:defRPr sz="3675" b="1">
                 <a:solidFill>
                   <a:srgbClr val="174D46"/>
@@ -2868,6 +2961,7 @@
               </a:defRPr>
             </a:lvl2pPr>
             <a:lvl3pPr>
+              <a:buNone/>
               <a:defRPr sz="3675" b="1">
                 <a:solidFill>
                   <a:srgbClr val="174D46"/>
@@ -2878,6 +2972,7 @@
               </a:defRPr>
             </a:lvl3pPr>
             <a:lvl4pPr>
+              <a:buNone/>
               <a:defRPr sz="3675" b="1">
                 <a:solidFill>
                   <a:srgbClr val="174D46"/>
@@ -2888,6 +2983,7 @@
               </a:defRPr>
             </a:lvl4pPr>
             <a:lvl5pPr>
+              <a:buNone/>
               <a:defRPr sz="3675" b="1">
                 <a:solidFill>
                   <a:srgbClr val="174D46"/>
@@ -2898,6 +2994,7 @@
               </a:defRPr>
             </a:lvl5pPr>
             <a:lvl6pPr>
+              <a:buNone/>
               <a:defRPr sz="3675" b="1">
                 <a:solidFill>
                   <a:srgbClr val="174D46"/>
@@ -2908,6 +3005,7 @@
               </a:defRPr>
             </a:lvl6pPr>
             <a:lvl7pPr>
+              <a:buNone/>
               <a:defRPr sz="3675" b="1">
                 <a:solidFill>
                   <a:srgbClr val="174D46"/>
@@ -2918,6 +3016,7 @@
               </a:defRPr>
             </a:lvl7pPr>
             <a:lvl8pPr>
+              <a:buNone/>
               <a:defRPr sz="3675" b="1">
                 <a:solidFill>
                   <a:srgbClr val="174D46"/>
@@ -2928,6 +3027,7 @@
               </a:defRPr>
             </a:lvl8pPr>
             <a:lvl9pPr>
+              <a:buNone/>
               <a:defRPr sz="3675" b="1">
                 <a:solidFill>
                   <a:srgbClr val="174D46"/>
@@ -2940,6 +3040,7 @@
           </a:lstStyle>
           <a:p xmlns:a="http://schemas.openxmlformats.org/drawingml/2006/main">
             <a:pPr>
+              <a:buNone/>
               <a:defRPr sz="3675" b="1">
                 <a:solidFill>
                   <a:srgbClr val="174D46"/>
@@ -3006,6 +3107,7 @@
               </a:defRPr>
             </a:defPPr>
             <a:lvl1pPr>
+              <a:buNone/>
               <a:defRPr sz="1725" b="0">
                 <a:solidFill>
                   <a:srgbClr val="253F39"/>
@@ -3016,6 +3118,7 @@
               </a:defRPr>
             </a:lvl1pPr>
             <a:lvl2pPr>
+              <a:buNone/>
               <a:defRPr sz="1725" b="0">
                 <a:solidFill>
                   <a:srgbClr val="253F39"/>
@@ -3026,6 +3129,7 @@
               </a:defRPr>
             </a:lvl2pPr>
             <a:lvl3pPr>
+              <a:buNone/>
               <a:defRPr sz="1725" b="0">
                 <a:solidFill>
                   <a:srgbClr val="253F39"/>
@@ -3036,6 +3140,7 @@
               </a:defRPr>
             </a:lvl3pPr>
             <a:lvl4pPr>
+              <a:buNone/>
               <a:defRPr sz="1725" b="0">
                 <a:solidFill>
                   <a:srgbClr val="253F39"/>
@@ -3046,6 +3151,7 @@
               </a:defRPr>
             </a:lvl4pPr>
             <a:lvl5pPr>
+              <a:buNone/>
               <a:defRPr sz="1725" b="0">
                 <a:solidFill>
                   <a:srgbClr val="253F39"/>
@@ -3056,6 +3162,7 @@
               </a:defRPr>
             </a:lvl5pPr>
             <a:lvl6pPr>
+              <a:buNone/>
               <a:defRPr sz="1725" b="0">
                 <a:solidFill>
                   <a:srgbClr val="253F39"/>
@@ -3066,6 +3173,7 @@
               </a:defRPr>
             </a:lvl6pPr>
             <a:lvl7pPr>
+              <a:buNone/>
               <a:defRPr sz="1725" b="0">
                 <a:solidFill>
                   <a:srgbClr val="253F39"/>
@@ -3076,6 +3184,7 @@
               </a:defRPr>
             </a:lvl7pPr>
             <a:lvl8pPr>
+              <a:buNone/>
               <a:defRPr sz="1725" b="0">
                 <a:solidFill>
                   <a:srgbClr val="253F39"/>
@@ -3086,6 +3195,7 @@
               </a:defRPr>
             </a:lvl8pPr>
             <a:lvl9pPr>
+              <a:buNone/>
               <a:defRPr sz="1725" b="0">
                 <a:solidFill>
                   <a:srgbClr val="253F39"/>
@@ -3098,6 +3208,7 @@
           </a:lstStyle>
           <a:p xmlns:a="http://schemas.openxmlformats.org/drawingml/2006/main">
             <a:pPr>
+              <a:buNone/>
               <a:defRPr sz="1725" b="0">
                 <a:solidFill>
                   <a:srgbClr val="253F39"/>
@@ -3164,6 +3275,7 @@
               </a:defRPr>
             </a:defPPr>
             <a:lvl1pPr>
+              <a:buNone/>
               <a:defRPr sz="1725" b="0">
                 <a:solidFill>
                   <a:srgbClr val="253F39"/>
@@ -3174,6 +3286,7 @@
               </a:defRPr>
             </a:lvl1pPr>
             <a:lvl2pPr>
+              <a:buNone/>
               <a:defRPr sz="1725" b="0">
                 <a:solidFill>
                   <a:srgbClr val="253F39"/>
@@ -3184,6 +3297,7 @@
               </a:defRPr>
             </a:lvl2pPr>
             <a:lvl3pPr>
+              <a:buNone/>
               <a:defRPr sz="1725" b="0">
                 <a:solidFill>
                   <a:srgbClr val="253F39"/>
@@ -3194,6 +3308,7 @@
               </a:defRPr>
             </a:lvl3pPr>
             <a:lvl4pPr>
+              <a:buNone/>
               <a:defRPr sz="1725" b="0">
                 <a:solidFill>
                   <a:srgbClr val="253F39"/>
@@ -3204,6 +3319,7 @@
               </a:defRPr>
             </a:lvl4pPr>
             <a:lvl5pPr>
+              <a:buNone/>
               <a:defRPr sz="1725" b="0">
                 <a:solidFill>
                   <a:srgbClr val="253F39"/>
@@ -3214,6 +3330,7 @@
               </a:defRPr>
             </a:lvl5pPr>
             <a:lvl6pPr>
+              <a:buNone/>
               <a:defRPr sz="1725" b="0">
                 <a:solidFill>
                   <a:srgbClr val="253F39"/>
@@ -3224,6 +3341,7 @@
               </a:defRPr>
             </a:lvl6pPr>
             <a:lvl7pPr>
+              <a:buNone/>
               <a:defRPr sz="1725" b="0">
                 <a:solidFill>
                   <a:srgbClr val="253F39"/>
@@ -3234,6 +3352,7 @@
               </a:defRPr>
             </a:lvl7pPr>
             <a:lvl8pPr>
+              <a:buNone/>
               <a:defRPr sz="1725" b="0">
                 <a:solidFill>
                   <a:srgbClr val="253F39"/>
@@ -3244,6 +3363,7 @@
               </a:defRPr>
             </a:lvl8pPr>
             <a:lvl9pPr>
+              <a:buNone/>
               <a:defRPr sz="1725" b="0">
                 <a:solidFill>
                   <a:srgbClr val="253F39"/>
@@ -3256,6 +3376,7 @@
           </a:lstStyle>
           <a:p xmlns:a="http://schemas.openxmlformats.org/drawingml/2006/main">
             <a:pPr>
+              <a:buNone/>
               <a:defRPr sz="1725" b="0">
                 <a:solidFill>
                   <a:srgbClr val="253F39"/>
@@ -3322,6 +3443,7 @@
               </a:defRPr>
             </a:defPPr>
             <a:lvl1pPr>
+              <a:buNone/>
               <a:defRPr sz="1725" b="1">
                 <a:solidFill>
                   <a:srgbClr val="253F39"/>
@@ -3332,6 +3454,7 @@
               </a:defRPr>
             </a:lvl1pPr>
             <a:lvl2pPr>
+              <a:buNone/>
               <a:defRPr sz="1725" b="1">
                 <a:solidFill>
                   <a:srgbClr val="253F39"/>
@@ -3342,6 +3465,7 @@
               </a:defRPr>
             </a:lvl2pPr>
             <a:lvl3pPr>
+              <a:buNone/>
               <a:defRPr sz="1725" b="1">
                 <a:solidFill>
                   <a:srgbClr val="253F39"/>
@@ -3352,6 +3476,7 @@
               </a:defRPr>
             </a:lvl3pPr>
             <a:lvl4pPr>
+              <a:buNone/>
               <a:defRPr sz="1725" b="1">
                 <a:solidFill>
                   <a:srgbClr val="253F39"/>
@@ -3362,6 +3487,7 @@
               </a:defRPr>
             </a:lvl4pPr>
             <a:lvl5pPr>
+              <a:buNone/>
               <a:defRPr sz="1725" b="1">
                 <a:solidFill>
                   <a:srgbClr val="253F39"/>
@@ -3372,6 +3498,7 @@
               </a:defRPr>
             </a:lvl5pPr>
             <a:lvl6pPr>
+              <a:buNone/>
               <a:defRPr sz="1725" b="1">
                 <a:solidFill>
                   <a:srgbClr val="253F39"/>
@@ -3382,6 +3509,7 @@
               </a:defRPr>
             </a:lvl6pPr>
             <a:lvl7pPr>
+              <a:buNone/>
               <a:defRPr sz="1725" b="1">
                 <a:solidFill>
                   <a:srgbClr val="253F39"/>
@@ -3392,6 +3520,7 @@
               </a:defRPr>
             </a:lvl7pPr>
             <a:lvl8pPr>
+              <a:buNone/>
               <a:defRPr sz="1725" b="1">
                 <a:solidFill>
                   <a:srgbClr val="253F39"/>
@@ -3402,6 +3531,7 @@
               </a:defRPr>
             </a:lvl8pPr>
             <a:lvl9pPr>
+              <a:buNone/>
               <a:defRPr sz="1725" b="1">
                 <a:solidFill>
                   <a:srgbClr val="253F39"/>
@@ -3414,6 +3544,7 @@
           </a:lstStyle>
           <a:p xmlns:a="http://schemas.openxmlformats.org/drawingml/2006/main">
             <a:pPr>
+              <a:buNone/>
               <a:defRPr sz="1725" b="1">
                 <a:solidFill>
                   <a:srgbClr val="253F39"/>
@@ -3480,6 +3611,7 @@
               </a:defRPr>
             </a:defPPr>
             <a:lvl1pPr>
+              <a:buNone/>
               <a:defRPr sz="1500" b="0">
                 <a:solidFill>
                   <a:srgbClr val="253F39"/>
@@ -3490,6 +3622,7 @@
               </a:defRPr>
             </a:lvl1pPr>
             <a:lvl2pPr>
+              <a:buNone/>
               <a:defRPr sz="1500" b="0">
                 <a:solidFill>
                   <a:srgbClr val="253F39"/>
@@ -3500,6 +3633,7 @@
               </a:defRPr>
             </a:lvl2pPr>
             <a:lvl3pPr>
+              <a:buNone/>
               <a:defRPr sz="1500" b="0">
                 <a:solidFill>
                   <a:srgbClr val="253F39"/>
@@ -3510,6 +3644,7 @@
               </a:defRPr>
             </a:lvl3pPr>
             <a:lvl4pPr>
+              <a:buNone/>
               <a:defRPr sz="1500" b="0">
                 <a:solidFill>
                   <a:srgbClr val="253F39"/>
@@ -3520,6 +3655,7 @@
               </a:defRPr>
             </a:lvl4pPr>
             <a:lvl5pPr>
+              <a:buNone/>
               <a:defRPr sz="1500" b="0">
                 <a:solidFill>
                   <a:srgbClr val="253F39"/>
@@ -3530,6 +3666,7 @@
               </a:defRPr>
             </a:lvl5pPr>
             <a:lvl6pPr>
+              <a:buNone/>
               <a:defRPr sz="1500" b="0">
                 <a:solidFill>
                   <a:srgbClr val="253F39"/>
@@ -3540,6 +3677,7 @@
               </a:defRPr>
             </a:lvl6pPr>
             <a:lvl7pPr>
+              <a:buNone/>
               <a:defRPr sz="1500" b="0">
                 <a:solidFill>
                   <a:srgbClr val="253F39"/>
@@ -3550,6 +3688,7 @@
               </a:defRPr>
             </a:lvl7pPr>
             <a:lvl8pPr>
+              <a:buNone/>
               <a:defRPr sz="1500" b="0">
                 <a:solidFill>
                   <a:srgbClr val="253F39"/>
@@ -3560,6 +3699,7 @@
               </a:defRPr>
             </a:lvl8pPr>
             <a:lvl9pPr>
+              <a:buNone/>
               <a:defRPr sz="1500" b="0">
                 <a:solidFill>
                   <a:srgbClr val="253F39"/>
@@ -3572,6 +3712,7 @@
           </a:lstStyle>
           <a:p xmlns:a="http://schemas.openxmlformats.org/drawingml/2006/main">
             <a:pPr>
+              <a:buNone/>
               <a:defRPr sz="1500" b="0">
                 <a:solidFill>
                   <a:srgbClr val="253F39"/>
@@ -3595,6 +3736,7 @@
           </a:p>
           <a:p xmlns:a="http://schemas.openxmlformats.org/drawingml/2006/main">
             <a:pPr>
+              <a:buNone/>
               <a:defRPr sz="1500" b="0">
                 <a:solidFill>
                   <a:srgbClr val="253F39"/>
@@ -3661,6 +3803,7 @@
               </a:defRPr>
             </a:defPPr>
             <a:lvl1pPr>
+              <a:buNone/>
               <a:defRPr sz="1575" b="1">
                 <a:solidFill>
                   <a:srgbClr val="174D46"/>
@@ -3671,6 +3814,7 @@
               </a:defRPr>
             </a:lvl1pPr>
             <a:lvl2pPr>
+              <a:buNone/>
               <a:defRPr sz="1575" b="1">
                 <a:solidFill>
                   <a:srgbClr val="174D46"/>
@@ -3681,6 +3825,7 @@
               </a:defRPr>
             </a:lvl2pPr>
             <a:lvl3pPr>
+              <a:buNone/>
               <a:defRPr sz="1575" b="1">
                 <a:solidFill>
                   <a:srgbClr val="174D46"/>
@@ -3691,6 +3836,7 @@
               </a:defRPr>
             </a:lvl3pPr>
             <a:lvl4pPr>
+              <a:buNone/>
               <a:defRPr sz="1575" b="1">
                 <a:solidFill>
                   <a:srgbClr val="174D46"/>
@@ -3701,6 +3847,7 @@
               </a:defRPr>
             </a:lvl4pPr>
             <a:lvl5pPr>
+              <a:buNone/>
               <a:defRPr sz="1575" b="1">
                 <a:solidFill>
                   <a:srgbClr val="174D46"/>
@@ -3711,6 +3858,7 @@
               </a:defRPr>
             </a:lvl5pPr>
             <a:lvl6pPr>
+              <a:buNone/>
               <a:defRPr sz="1575" b="1">
                 <a:solidFill>
                   <a:srgbClr val="174D46"/>
@@ -3721,6 +3869,7 @@
               </a:defRPr>
             </a:lvl6pPr>
             <a:lvl7pPr>
+              <a:buNone/>
               <a:defRPr sz="1575" b="1">
                 <a:solidFill>
                   <a:srgbClr val="174D46"/>
@@ -3731,6 +3880,7 @@
               </a:defRPr>
             </a:lvl7pPr>
             <a:lvl8pPr>
+              <a:buNone/>
               <a:defRPr sz="1575" b="1">
                 <a:solidFill>
                   <a:srgbClr val="174D46"/>
@@ -3741,6 +3891,7 @@
               </a:defRPr>
             </a:lvl8pPr>
             <a:lvl9pPr>
+              <a:buNone/>
               <a:defRPr sz="1575" b="1">
                 <a:solidFill>
                   <a:srgbClr val="174D46"/>
@@ -3753,6 +3904,7 @@
           </a:lstStyle>
           <a:p xmlns:a="http://schemas.openxmlformats.org/drawingml/2006/main">
             <a:pPr>
+              <a:buNone/>
               <a:defRPr sz="1575" b="1">
                 <a:solidFill>
                   <a:srgbClr val="174D46"/>
@@ -3819,6 +3971,7 @@
               </a:defRPr>
             </a:defPPr>
             <a:lvl1pPr>
+              <a:buNone/>
               <a:defRPr sz="1725" b="0">
                 <a:solidFill>
                   <a:srgbClr val="253F39"/>
@@ -3829,6 +3982,7 @@
               </a:defRPr>
             </a:lvl1pPr>
             <a:lvl2pPr>
+              <a:buNone/>
               <a:defRPr sz="1725" b="0">
                 <a:solidFill>
                   <a:srgbClr val="253F39"/>
@@ -3839,6 +3993,7 @@
               </a:defRPr>
             </a:lvl2pPr>
             <a:lvl3pPr>
+              <a:buNone/>
               <a:defRPr sz="1725" b="0">
                 <a:solidFill>
                   <a:srgbClr val="253F39"/>
@@ -3849,6 +4004,7 @@
               </a:defRPr>
             </a:lvl3pPr>
             <a:lvl4pPr>
+              <a:buNone/>
               <a:defRPr sz="1725" b="0">
                 <a:solidFill>
                   <a:srgbClr val="253F39"/>
@@ -3859,6 +4015,7 @@
               </a:defRPr>
             </a:lvl4pPr>
             <a:lvl5pPr>
+              <a:buNone/>
               <a:defRPr sz="1725" b="0">
                 <a:solidFill>
                   <a:srgbClr val="253F39"/>
@@ -3869,6 +4026,7 @@
               </a:defRPr>
             </a:lvl5pPr>
             <a:lvl6pPr>
+              <a:buNone/>
               <a:defRPr sz="1725" b="0">
                 <a:solidFill>
                   <a:srgbClr val="253F39"/>
@@ -3879,6 +4037,7 @@
               </a:defRPr>
             </a:lvl6pPr>
             <a:lvl7pPr>
+              <a:buNone/>
               <a:defRPr sz="1725" b="0">
                 <a:solidFill>
                   <a:srgbClr val="253F39"/>
@@ -3889,6 +4048,7 @@
               </a:defRPr>
             </a:lvl7pPr>
             <a:lvl8pPr>
+              <a:buNone/>
               <a:defRPr sz="1725" b="0">
                 <a:solidFill>
                   <a:srgbClr val="253F39"/>
@@ -3899,6 +4059,7 @@
               </a:defRPr>
             </a:lvl8pPr>
             <a:lvl9pPr>
+              <a:buNone/>
               <a:defRPr sz="1725" b="0">
                 <a:solidFill>
                   <a:srgbClr val="253F39"/>
@@ -3911,6 +4072,7 @@
           </a:lstStyle>
           <a:p xmlns:a="http://schemas.openxmlformats.org/drawingml/2006/main">
             <a:pPr>
+              <a:buNone/>
               <a:defRPr sz="1725" b="0">
                 <a:solidFill>
                   <a:srgbClr val="253F39"/>
@@ -3934,6 +4096,7 @@
           </a:p>
           <a:p xmlns:a="http://schemas.openxmlformats.org/drawingml/2006/main">
             <a:pPr>
+              <a:buNone/>
               <a:defRPr sz="1725" b="0">
                 <a:solidFill>
                   <a:srgbClr val="253F39"/>
@@ -3957,6 +4120,7 @@
           </a:p>
           <a:p xmlns:a="http://schemas.openxmlformats.org/drawingml/2006/main">
             <a:pPr>
+              <a:buNone/>
               <a:defRPr sz="1725" b="0">
                 <a:solidFill>
                   <a:srgbClr val="253F39"/>
@@ -3975,11 +4139,12 @@
                 <a:ea typeface="Helvetica Neue"/>
                 <a:cs typeface="Helvetica Neue"/>
               </a:rPr>
-              <a:t>First users: recruit grocery operators for</a:t>
+              <a:t>First users: email independent grocers.</a:t>
             </a:r>
           </a:p>
           <a:p xmlns:a="http://schemas.openxmlformats.org/drawingml/2006/main">
             <a:pPr>
+              <a:buNone/>
               <a:defRPr sz="1725" b="0">
                 <a:solidFill>
                   <a:srgbClr val="253F39"/>
@@ -3998,11 +4163,12 @@
                 <a:ea typeface="Helvetica Neue"/>
                 <a:cs typeface="Helvetica Neue"/>
               </a:rPr>
-              <a:t>supervised historical pilots. Measure</a:t>
+              <a:t>Offer supervised pilots with stock exports.</a:t>
             </a:r>
           </a:p>
           <a:p xmlns:a="http://schemas.openxmlformats.org/drawingml/2006/main">
             <a:pPr>
+              <a:buNone/>
               <a:defRPr sz="1725" b="0">
                 <a:solidFill>
                   <a:srgbClr val="253F39"/>
@@ -4021,7 +4187,7 @@
                 <a:ea typeface="Helvetica Neue"/>
                 <a:cs typeface="Helvetica Neue"/>
               </a:rPr>
-              <a:t>investigation time and supported decisions.</a:t>
+              <a:t>Measure time and decision quality.</a:t>
             </a:r>
           </a:p>
         </p:txBody>
@@ -4069,6 +4235,7 @@
               </a:defRPr>
             </a:defPPr>
             <a:lvl1pPr>
+              <a:buNone/>
               <a:defRPr sz="1500" b="0">
                 <a:solidFill>
                   <a:srgbClr val="345D54"/>
@@ -4079,6 +4246,7 @@
               </a:defRPr>
             </a:lvl1pPr>
             <a:lvl2pPr>
+              <a:buNone/>
               <a:defRPr sz="1500" b="0">
                 <a:solidFill>
                   <a:srgbClr val="345D54"/>
@@ -4089,6 +4257,7 @@
               </a:defRPr>
             </a:lvl2pPr>
             <a:lvl3pPr>
+              <a:buNone/>
               <a:defRPr sz="1500" b="0">
                 <a:solidFill>
                   <a:srgbClr val="345D54"/>
@@ -4099,6 +4268,7 @@
               </a:defRPr>
             </a:lvl3pPr>
             <a:lvl4pPr>
+              <a:buNone/>
               <a:defRPr sz="1500" b="0">
                 <a:solidFill>
                   <a:srgbClr val="345D54"/>
@@ -4109,6 +4279,7 @@
               </a:defRPr>
             </a:lvl4pPr>
             <a:lvl5pPr>
+              <a:buNone/>
               <a:defRPr sz="1500" b="0">
                 <a:solidFill>
                   <a:srgbClr val="345D54"/>
@@ -4119,6 +4290,7 @@
               </a:defRPr>
             </a:lvl5pPr>
             <a:lvl6pPr>
+              <a:buNone/>
               <a:defRPr sz="1500" b="0">
                 <a:solidFill>
                   <a:srgbClr val="345D54"/>
@@ -4129,6 +4301,7 @@
               </a:defRPr>
             </a:lvl6pPr>
             <a:lvl7pPr>
+              <a:buNone/>
               <a:defRPr sz="1500" b="0">
                 <a:solidFill>
                   <a:srgbClr val="345D54"/>
@@ -4139,6 +4312,7 @@
               </a:defRPr>
             </a:lvl7pPr>
             <a:lvl8pPr>
+              <a:buNone/>
               <a:defRPr sz="1500" b="0">
                 <a:solidFill>
                   <a:srgbClr val="345D54"/>
@@ -4149,6 +4323,7 @@
               </a:defRPr>
             </a:lvl8pPr>
             <a:lvl9pPr>
+              <a:buNone/>
               <a:defRPr sz="1500" b="0">
                 <a:solidFill>
                   <a:srgbClr val="345D54"/>
@@ -4161,6 +4336,7 @@
           </a:lstStyle>
           <a:p xmlns:a="http://schemas.openxmlformats.org/drawingml/2006/main">
             <a:pPr>
+              <a:buNone/>
               <a:defRPr sz="1500" b="0">
                 <a:solidFill>
                   <a:srgbClr val="345D54"/>

</xml_diff>